<commit_message>
Remove mark-weight badges/recap slide, add References and Thank You
Section headings keep their titles but drop the "N MARKS" badges, and
the "Total: 30 Marks" recap slide is removed. Deck now closes with a
References slide and a Thank You slide instead.

Co-Authored-By: Claude Sonnet 5 <noreply@anthropic.com>
Claude-Session: https://claude.ai/code/session_01NtKqrpTuv6riB3qBRrfQW7
</commit_message>
<xml_diff>
--- a/Review-Presentation-Rubric.pptx
+++ b/Review-Presentation-Rubric.pptx
@@ -22,9 +22,10 @@
     <p:sldId id="270" r:id="rId16"/>
     <p:sldId id="271" r:id="rId17"/>
     <p:sldId id="272" r:id="rId18"/>
+    <p:sldId id="273" r:id="rId19"/>
   </p:sldIdLst>
   <p:notesMasterIdLst>
-    <p:notesMasterId r:id="rId19"/>
+    <p:notesMasterId r:id="rId20"/>
   </p:notesMasterIdLst>
   <p:sldSz cx="12188952" cy="6858000"/>
   <p:notesSz cx="6858000" cy="12188952"/>
@@ -1246,6 +1247,94 @@
             <a:fld id="{F7021451-1387-4CA6-816F-3879F97B5CBC}" type="slidenum">
               <a:rPr lang="en-US"/>
               <a:t>17</a:t>
+            </a:fld>
+            <a:endParaRPr lang="en-US"/>
+          </a:p>
+        </p:txBody>
+      </p:sp>
+    </p:spTree>
+    <p:extLst>
+      <p:ext uri="{BB962C8B-B14F-4D97-AF65-F5344CB8AC3E}">
+        <p14:creationId xmlns:p14="http://schemas.microsoft.com/office/powerpoint/2010/main" val="1024086991"/>
+      </p:ext>
+    </p:extLst>
+  </p:cSld>
+  <p:clrMapOvr>
+    <a:masterClrMapping/>
+  </p:clrMapOvr>
+</p:notes>
+</file>
+
+<file path=ppt/notesSlides/notesSlide18.xml><?xml version="1.0" encoding="utf-8"?>
+<p:notes xmlns:a="http://schemas.openxmlformats.org/drawingml/2006/main" xmlns:r="http://schemas.openxmlformats.org/officeDocument/2006/relationships" xmlns:p="http://schemas.openxmlformats.org/presentationml/2006/main">
+  <p:cSld>
+    <p:spTree>
+      <p:nvGrpSpPr>
+        <p:cNvPr id="1" name=""/>
+        <p:cNvGrpSpPr/>
+        <p:nvPr/>
+      </p:nvGrpSpPr>
+      <p:grpSpPr>
+        <a:xfrm>
+          <a:off x="0" y="0"/>
+          <a:ext cx="0" cy="0"/>
+          <a:chOff x="0" y="0"/>
+          <a:chExt cx="0" cy="0"/>
+        </a:xfrm>
+      </p:grpSpPr>
+      <p:sp>
+        <p:nvSpPr>
+          <p:cNvPr id="2" name="Slide Image Placeholder 1"/>
+          <p:cNvSpPr>
+            <a:spLocks noGrp="1" noRot="1" noChangeAspect="1"/>
+          </p:cNvSpPr>
+          <p:nvPr>
+            <p:ph type="sldImg"/>
+          </p:nvPr>
+        </p:nvSpPr>
+        <p:spPr/>
+      </p:sp>
+      <p:sp>
+        <p:nvSpPr>
+          <p:cNvPr id="3" name="Notes Placeholder 2"/>
+          <p:cNvSpPr>
+            <a:spLocks noGrp="1"/>
+          </p:cNvSpPr>
+          <p:nvPr>
+            <p:ph type="body" idx="1"/>
+          </p:nvPr>
+        </p:nvSpPr>
+        <p:spPr/>
+        <p:txBody>
+          <a:bodyPr/>
+          <a:lstStyle/>
+          <a:p>
+            <a:r>
+              <a:rPr lang="en-US" dirty="0"/>
+              <a:t/>
+            </a:r>
+            <a:endParaRPr lang="en-US" dirty="0"/>
+          </a:p>
+        </p:txBody>
+      </p:sp>
+      <p:sp>
+        <p:nvSpPr>
+          <p:cNvPr id="4" name="Slide Number Placeholder 3"/>
+          <p:cNvSpPr>
+            <a:spLocks noGrp="1"/>
+          </p:cNvSpPr>
+          <p:nvPr>
+            <p:ph type="sldNum" sz="quarter" idx="10"/>
+          </p:nvPr>
+        </p:nvSpPr>
+        <p:spPr/>
+        <p:txBody>
+          <a:bodyPr/>
+          <a:lstStyle/>
+          <a:p>
+            <a:fld id="{F7021451-1387-4CA6-816F-3879F97B5CBC}" type="slidenum">
+              <a:rPr lang="en-US"/>
+              <a:t>18</a:t>
             </a:fld>
             <a:endParaRPr lang="en-US"/>
           </a:p>
@@ -7472,7 +7561,7 @@
         </p:nvSpPr>
         <p:spPr>
           <a:xfrm>
-            <a:off x="548640" y="502920"/>
+            <a:off x="548640" y="457200"/>
             <a:ext cx="10972800" cy="640080"/>
           </a:xfrm>
           <a:prstGeom prst="rect">
@@ -7497,7 +7586,7 @@
                 <a:ea typeface="Cambria" pitchFamily="34" charset="-122"/>
                 <a:cs typeface="Cambria" pitchFamily="34" charset="-120"/>
               </a:rPr>
-              <a:t>Total: 30 Marks</a:t>
+              <a:t>References</a:t>
             </a:r>
             <a:endParaRPr lang="en-US" sz="3000" dirty="0"/>
           </a:p>
@@ -7505,52 +7594,13 @@
       </p:sp>
       <p:sp>
         <p:nvSpPr>
-          <p:cNvPr id="3" name="Text 1"/>
-          <p:cNvSpPr txBox="1"/>
-          <p:nvPr/>
-        </p:nvSpPr>
-        <p:spPr>
-          <a:xfrm>
-            <a:off x="548640" y="1097280"/>
-            <a:ext cx="10972800" cy="365760"/>
-          </a:xfrm>
-          <a:prstGeom prst="rect">
-            <a:avLst/>
-          </a:prstGeom>
-          <a:noFill/>
-          <a:ln/>
-        </p:spPr>
-        <p:txBody>
-          <a:bodyPr wrap="square" lIns="0" tIns="0" rIns="0" bIns="0" rtlCol="0" anchor="ctr"/>
-          <a:lstStyle/>
-          <a:p>
-            <a:pPr indent="0" marL="0">
-              <a:buNone/>
-            </a:pPr>
-            <a:r>
-              <a:rPr lang="en-US" sz="1400" i="1" dirty="0">
-                <a:solidFill>
-                  <a:srgbClr val="CADCFC"/>
-                </a:solidFill>
-                <a:latin typeface="Calibri" pitchFamily="34" charset="0"/>
-                <a:ea typeface="Calibri" pitchFamily="34" charset="-122"/>
-                <a:cs typeface="Calibri" pitchFamily="34" charset="-120"/>
-              </a:rPr>
-              <a:t>First Review rubric – this deck, section by section</a:t>
-            </a:r>
-            <a:endParaRPr lang="en-US" sz="1400" dirty="0"/>
-          </a:p>
-        </p:txBody>
-      </p:sp>
-      <p:sp>
-        <p:nvSpPr>
-          <p:cNvPr id="4" name="Shape 2"/>
+          <p:cNvPr id="3" name="Shape 1"/>
           <p:cNvSpPr/>
           <p:nvPr/>
         </p:nvSpPr>
         <p:spPr>
           <a:xfrm>
-            <a:off x="10424160" y="411480"/>
+            <a:off x="10424160" y="320040"/>
             <a:ext cx="822960" cy="822960"/>
           </a:xfrm>
           <a:prstGeom prst="ellipse">
@@ -7564,7 +7614,7 @@
       </p:sp>
       <p:pic>
         <p:nvPicPr>
-          <p:cNvPr id="5" name="Image 0" descr="preencoded.png">    </p:cNvPr>
+          <p:cNvPr id="4" name="Image 0" descr="preencoded.png">    </p:cNvPr>
           <p:cNvPicPr>
             <a:picLocks noChangeAspect="1"/>
           </p:cNvPicPr>
@@ -7578,7 +7628,7 @@
         </p:blipFill>
         <p:spPr>
           <a:xfrm>
-            <a:off x="10522915" y="510235"/>
+            <a:off x="10522915" y="418795"/>
             <a:ext cx="625450" cy="625450"/>
           </a:xfrm>
           <a:prstGeom prst="rect">
@@ -7586,1471 +7636,211 @@
           </a:prstGeom>
         </p:spPr>
       </p:pic>
-      <p:graphicFrame>
-        <p:nvGraphicFramePr>
-          <p:cNvPr id="18" name="Table 0"/>
-          <p:cNvGraphicFramePr>
-            <a:graphicFrameLocks noGrp="1"/>
-          </p:cNvGraphicFramePr>
-          <p:nvPr>
-            <p:extLst>
-              <p:ext uri="{D42A27DB-BD31-4B8C-83A1-F6EECF244321}">
-                <p14:modId xmlns:p14="http://schemas.microsoft.com/office/powerpoint/2010/main" val="1579011935"/>
-              </p:ext>
-            </p:extLst>
-          </p:nvPr>
-        </p:nvGraphicFramePr>
-        <p:xfrm>
-          <a:off x="914400" y="1783080"/>
-          <a:ext cx="10360152" cy="4023360"/>
-        </p:xfrm>
-        <a:graphic>
-          <a:graphicData uri="http://schemas.openxmlformats.org/drawingml/2006/table">
-            <a:tbl>
-              <a:tblPr/>
-              <a:tblGrid>
-                <a:gridCol w="822960"/>
-                <a:gridCol w="8074152"/>
-                <a:gridCol w="1463040"/>
-              </a:tblGrid>
-              <a:tr h="502920">
-                <a:tc>
-                  <a:txBody>
-                    <a:bodyPr/>
-                    <a:lstStyle/>
-                    <a:p>
-                      <a:pPr indent="0" marL="0">
-                        <a:buNone/>
-                      </a:pPr>
-                      <a:r>
-                        <a:rPr lang="en-US" sz="1500" b="1" dirty="0">
-                          <a:solidFill>
-                            <a:srgbClr val="141B45"/>
-                          </a:solidFill>
-                          <a:latin typeface="Calibri" pitchFamily="34" charset="0"/>
-                          <a:ea typeface="Calibri" pitchFamily="34" charset="-122"/>
-                          <a:cs typeface="Calibri" pitchFamily="34" charset="-120"/>
-                        </a:rPr>
-                        <a:t>#</a:t>
-                      </a:r>
-                      <a:endParaRPr lang="en-US" sz="1500" dirty="0">
-                        <a:latin typeface="Calibri" charset="0"/>
-                        <a:ea typeface="Calibri" charset="0"/>
-                        <a:cs typeface="Calibri" charset="0"/>
-                      </a:endParaRPr>
-                    </a:p>
-                  </a:txBody>
-                  <a:tcPr marL="91440" marR="91440" marT="45720" marB="45720" anchor="ctr">
-                    <a:lnL w="12700" cap="flat" cmpd="sng" algn="ctr">
-                      <a:solidFill>
-                        <a:srgbClr val="3A4694"/>
-                      </a:solidFill>
-                      <a:prstDash val="solid"/>
-                      <a:round/>
-                      <a:headEnd type="none" w="med" len="med"/>
-                      <a:tailEnd type="none" w="med" len="med"/>
-                    </a:lnL>
-                    <a:lnR w="12700" cap="flat" cmpd="sng" algn="ctr">
-                      <a:solidFill>
-                        <a:srgbClr val="3A4694"/>
-                      </a:solidFill>
-                      <a:prstDash val="solid"/>
-                      <a:round/>
-                      <a:headEnd type="none" w="med" len="med"/>
-                      <a:tailEnd type="none" w="med" len="med"/>
-                    </a:lnR>
-                    <a:lnT w="12700" cap="flat" cmpd="sng" algn="ctr">
-                      <a:solidFill>
-                        <a:srgbClr val="3A4694"/>
-                      </a:solidFill>
-                      <a:prstDash val="solid"/>
-                      <a:round/>
-                      <a:headEnd type="none" w="med" len="med"/>
-                      <a:tailEnd type="none" w="med" len="med"/>
-                    </a:lnT>
-                    <a:lnB w="12700" cap="flat" cmpd="sng" algn="ctr">
-                      <a:solidFill>
-                        <a:srgbClr val="3A4694"/>
-                      </a:solidFill>
-                      <a:prstDash val="solid"/>
-                      <a:round/>
-                      <a:headEnd type="none" w="med" len="med"/>
-                      <a:tailEnd type="none" w="med" len="med"/>
-                    </a:lnB>
-                    <a:solidFill>
-                      <a:srgbClr val="CADCFC"/>
-                    </a:solidFill>
-                  </a:tcPr>
-                </a:tc>
-                <a:tc>
-                  <a:txBody>
-                    <a:bodyPr/>
-                    <a:lstStyle/>
-                    <a:p>
-                      <a:pPr indent="0" marL="0">
-                        <a:buNone/>
-                      </a:pPr>
-                      <a:r>
-                        <a:rPr lang="en-US" sz="1500" b="1" dirty="0">
-                          <a:solidFill>
-                            <a:srgbClr val="141B45"/>
-                          </a:solidFill>
-                          <a:latin typeface="Calibri" pitchFamily="34" charset="0"/>
-                          <a:ea typeface="Calibri" pitchFamily="34" charset="-122"/>
-                          <a:cs typeface="Calibri" pitchFamily="34" charset="-120"/>
-                        </a:rPr>
-                        <a:t>Rubric Section</a:t>
-                      </a:r>
-                      <a:endParaRPr lang="en-US" sz="1500" dirty="0">
-                        <a:latin typeface="Calibri" charset="0"/>
-                        <a:ea typeface="Calibri" charset="0"/>
-                        <a:cs typeface="Calibri" charset="0"/>
-                      </a:endParaRPr>
-                    </a:p>
-                  </a:txBody>
-                  <a:tcPr marL="91440" marR="91440" marT="45720" marB="45720" anchor="ctr">
-                    <a:lnL w="12700" cap="flat" cmpd="sng" algn="ctr">
-                      <a:solidFill>
-                        <a:srgbClr val="3A4694"/>
-                      </a:solidFill>
-                      <a:prstDash val="solid"/>
-                      <a:round/>
-                      <a:headEnd type="none" w="med" len="med"/>
-                      <a:tailEnd type="none" w="med" len="med"/>
-                    </a:lnL>
-                    <a:lnR w="12700" cap="flat" cmpd="sng" algn="ctr">
-                      <a:solidFill>
-                        <a:srgbClr val="3A4694"/>
-                      </a:solidFill>
-                      <a:prstDash val="solid"/>
-                      <a:round/>
-                      <a:headEnd type="none" w="med" len="med"/>
-                      <a:tailEnd type="none" w="med" len="med"/>
-                    </a:lnR>
-                    <a:lnT w="12700" cap="flat" cmpd="sng" algn="ctr">
-                      <a:solidFill>
-                        <a:srgbClr val="3A4694"/>
-                      </a:solidFill>
-                      <a:prstDash val="solid"/>
-                      <a:round/>
-                      <a:headEnd type="none" w="med" len="med"/>
-                      <a:tailEnd type="none" w="med" len="med"/>
-                    </a:lnT>
-                    <a:lnB w="12700" cap="flat" cmpd="sng" algn="ctr">
-                      <a:solidFill>
-                        <a:srgbClr val="3A4694"/>
-                      </a:solidFill>
-                      <a:prstDash val="solid"/>
-                      <a:round/>
-                      <a:headEnd type="none" w="med" len="med"/>
-                      <a:tailEnd type="none" w="med" len="med"/>
-                    </a:lnB>
-                    <a:solidFill>
-                      <a:srgbClr val="CADCFC"/>
-                    </a:solidFill>
-                  </a:tcPr>
-                </a:tc>
-                <a:tc>
-                  <a:txBody>
-                    <a:bodyPr/>
-                    <a:lstStyle/>
-                    <a:p>
-                      <a:pPr algn="ctr" indent="0" marL="0">
-                        <a:buNone/>
-                      </a:pPr>
-                      <a:r>
-                        <a:rPr lang="en-US" sz="1500" b="1" dirty="0">
-                          <a:solidFill>
-                            <a:srgbClr val="141B45"/>
-                          </a:solidFill>
-                          <a:latin typeface="Calibri" pitchFamily="34" charset="0"/>
-                          <a:ea typeface="Calibri" pitchFamily="34" charset="-122"/>
-                          <a:cs typeface="Calibri" pitchFamily="34" charset="-120"/>
-                        </a:rPr>
-                        <a:t>Marks</a:t>
-                      </a:r>
-                      <a:endParaRPr lang="en-US" sz="1500" dirty="0">
-                        <a:latin typeface="Calibri" charset="0"/>
-                        <a:ea typeface="Calibri" charset="0"/>
-                        <a:cs typeface="Calibri" charset="0"/>
-                      </a:endParaRPr>
-                    </a:p>
-                  </a:txBody>
-                  <a:tcPr marL="91440" marR="91440" marT="45720" marB="45720" anchor="ctr">
-                    <a:lnL w="12700" cap="flat" cmpd="sng" algn="ctr">
-                      <a:solidFill>
-                        <a:srgbClr val="3A4694"/>
-                      </a:solidFill>
-                      <a:prstDash val="solid"/>
-                      <a:round/>
-                      <a:headEnd type="none" w="med" len="med"/>
-                      <a:tailEnd type="none" w="med" len="med"/>
-                    </a:lnL>
-                    <a:lnR w="12700" cap="flat" cmpd="sng" algn="ctr">
-                      <a:solidFill>
-                        <a:srgbClr val="3A4694"/>
-                      </a:solidFill>
-                      <a:prstDash val="solid"/>
-                      <a:round/>
-                      <a:headEnd type="none" w="med" len="med"/>
-                      <a:tailEnd type="none" w="med" len="med"/>
-                    </a:lnR>
-                    <a:lnT w="12700" cap="flat" cmpd="sng" algn="ctr">
-                      <a:solidFill>
-                        <a:srgbClr val="3A4694"/>
-                      </a:solidFill>
-                      <a:prstDash val="solid"/>
-                      <a:round/>
-                      <a:headEnd type="none" w="med" len="med"/>
-                      <a:tailEnd type="none" w="med" len="med"/>
-                    </a:lnT>
-                    <a:lnB w="12700" cap="flat" cmpd="sng" algn="ctr">
-                      <a:solidFill>
-                        <a:srgbClr val="3A4694"/>
-                      </a:solidFill>
-                      <a:prstDash val="solid"/>
-                      <a:round/>
-                      <a:headEnd type="none" w="med" len="med"/>
-                      <a:tailEnd type="none" w="med" len="med"/>
-                    </a:lnB>
-                    <a:solidFill>
-                      <a:srgbClr val="CADCFC"/>
-                    </a:solidFill>
-                  </a:tcPr>
-                </a:tc>
-              </a:tr>
-              <a:tr h="566928">
-                <a:tc>
-                  <a:txBody>
-                    <a:bodyPr/>
-                    <a:lstStyle/>
-                    <a:p>
-                      <a:pPr indent="0" marL="0">
-                        <a:buNone/>
-                      </a:pPr>
-                      <a:r>
-                        <a:rPr lang="en-US" sz="1500" dirty="0">
-                          <a:solidFill>
-                            <a:srgbClr val="FFFFFF"/>
-                          </a:solidFill>
-                          <a:latin typeface="Calibri" pitchFamily="34" charset="0"/>
-                          <a:ea typeface="Calibri" pitchFamily="34" charset="-122"/>
-                          <a:cs typeface="Calibri" pitchFamily="34" charset="-120"/>
-                        </a:rPr>
-                        <a:t>1</a:t>
-                      </a:r>
-                      <a:endParaRPr lang="en-US" sz="1500" dirty="0">
-                        <a:latin typeface="Calibri" charset="0"/>
-                        <a:ea typeface="Calibri" charset="0"/>
-                        <a:cs typeface="Calibri" charset="0"/>
-                      </a:endParaRPr>
-                    </a:p>
-                  </a:txBody>
-                  <a:tcPr marL="91440" marR="91440" marT="45720" marB="45720" anchor="ctr">
-                    <a:lnL w="12700" cap="flat" cmpd="sng" algn="ctr">
-                      <a:solidFill>
-                        <a:srgbClr val="3A4694"/>
-                      </a:solidFill>
-                      <a:prstDash val="solid"/>
-                      <a:round/>
-                      <a:headEnd type="none" w="med" len="med"/>
-                      <a:tailEnd type="none" w="med" len="med"/>
-                    </a:lnL>
-                    <a:lnR w="12700" cap="flat" cmpd="sng" algn="ctr">
-                      <a:solidFill>
-                        <a:srgbClr val="3A4694"/>
-                      </a:solidFill>
-                      <a:prstDash val="solid"/>
-                      <a:round/>
-                      <a:headEnd type="none" w="med" len="med"/>
-                      <a:tailEnd type="none" w="med" len="med"/>
-                    </a:lnR>
-                    <a:lnT w="12700" cap="flat" cmpd="sng" algn="ctr">
-                      <a:solidFill>
-                        <a:srgbClr val="3A4694"/>
-                      </a:solidFill>
-                      <a:prstDash val="solid"/>
-                      <a:round/>
-                      <a:headEnd type="none" w="med" len="med"/>
-                      <a:tailEnd type="none" w="med" len="med"/>
-                    </a:lnT>
-                    <a:lnB w="12700" cap="flat" cmpd="sng" algn="ctr">
-                      <a:solidFill>
-                        <a:srgbClr val="3A4694"/>
-                      </a:solidFill>
-                      <a:prstDash val="solid"/>
-                      <a:round/>
-                      <a:headEnd type="none" w="med" len="med"/>
-                      <a:tailEnd type="none" w="med" len="med"/>
-                    </a:lnB>
-                    <a:solidFill>
-                      <a:srgbClr val="141B45"/>
-                    </a:solidFill>
-                  </a:tcPr>
-                </a:tc>
-                <a:tc>
-                  <a:txBody>
-                    <a:bodyPr/>
-                    <a:lstStyle/>
-                    <a:p>
-                      <a:pPr indent="0" marL="0">
-                        <a:buNone/>
-                      </a:pPr>
-                      <a:r>
-                        <a:rPr lang="en-US" sz="1500" dirty="0">
-                          <a:solidFill>
-                            <a:srgbClr val="FFFFFF"/>
-                          </a:solidFill>
-                          <a:latin typeface="Calibri" pitchFamily="34" charset="0"/>
-                          <a:ea typeface="Calibri" pitchFamily="34" charset="-122"/>
-                          <a:cs typeface="Calibri" pitchFamily="34" charset="-120"/>
-                        </a:rPr>
-                        <a:t>Problem Definition</a:t>
-                      </a:r>
-                      <a:endParaRPr lang="en-US" sz="1500" dirty="0">
-                        <a:latin typeface="Calibri" charset="0"/>
-                        <a:ea typeface="Calibri" charset="0"/>
-                        <a:cs typeface="Calibri" charset="0"/>
-                      </a:endParaRPr>
-                    </a:p>
-                  </a:txBody>
-                  <a:tcPr marL="91440" marR="91440" marT="45720" marB="45720" anchor="ctr">
-                    <a:lnL w="12700" cap="flat" cmpd="sng" algn="ctr">
-                      <a:solidFill>
-                        <a:srgbClr val="3A4694"/>
-                      </a:solidFill>
-                      <a:prstDash val="solid"/>
-                      <a:round/>
-                      <a:headEnd type="none" w="med" len="med"/>
-                      <a:tailEnd type="none" w="med" len="med"/>
-                    </a:lnL>
-                    <a:lnR w="12700" cap="flat" cmpd="sng" algn="ctr">
-                      <a:solidFill>
-                        <a:srgbClr val="3A4694"/>
-                      </a:solidFill>
-                      <a:prstDash val="solid"/>
-                      <a:round/>
-                      <a:headEnd type="none" w="med" len="med"/>
-                      <a:tailEnd type="none" w="med" len="med"/>
-                    </a:lnR>
-                    <a:lnT w="12700" cap="flat" cmpd="sng" algn="ctr">
-                      <a:solidFill>
-                        <a:srgbClr val="3A4694"/>
-                      </a:solidFill>
-                      <a:prstDash val="solid"/>
-                      <a:round/>
-                      <a:headEnd type="none" w="med" len="med"/>
-                      <a:tailEnd type="none" w="med" len="med"/>
-                    </a:lnT>
-                    <a:lnB w="12700" cap="flat" cmpd="sng" algn="ctr">
-                      <a:solidFill>
-                        <a:srgbClr val="3A4694"/>
-                      </a:solidFill>
-                      <a:prstDash val="solid"/>
-                      <a:round/>
-                      <a:headEnd type="none" w="med" len="med"/>
-                      <a:tailEnd type="none" w="med" len="med"/>
-                    </a:lnB>
-                    <a:solidFill>
-                      <a:srgbClr val="141B45"/>
-                    </a:solidFill>
-                  </a:tcPr>
-                </a:tc>
-                <a:tc>
-                  <a:txBody>
-                    <a:bodyPr/>
-                    <a:lstStyle/>
-                    <a:p>
-                      <a:pPr algn="ctr" indent="0" marL="0">
-                        <a:buNone/>
-                      </a:pPr>
-                      <a:r>
-                        <a:rPr lang="en-US" sz="1500" b="1" dirty="0">
-                          <a:solidFill>
-                            <a:srgbClr val="FFFFFF"/>
-                          </a:solidFill>
-                          <a:latin typeface="Calibri" pitchFamily="34" charset="0"/>
-                          <a:ea typeface="Calibri" pitchFamily="34" charset="-122"/>
-                          <a:cs typeface="Calibri" pitchFamily="34" charset="-120"/>
-                        </a:rPr>
-                        <a:t>4</a:t>
-                      </a:r>
-                      <a:endParaRPr lang="en-US" sz="1500" dirty="0">
-                        <a:latin typeface="Calibri" charset="0"/>
-                        <a:ea typeface="Calibri" charset="0"/>
-                        <a:cs typeface="Calibri" charset="0"/>
-                      </a:endParaRPr>
-                    </a:p>
-                  </a:txBody>
-                  <a:tcPr marL="91440" marR="91440" marT="45720" marB="45720" anchor="ctr">
-                    <a:lnL w="12700" cap="flat" cmpd="sng" algn="ctr">
-                      <a:solidFill>
-                        <a:srgbClr val="3A4694"/>
-                      </a:solidFill>
-                      <a:prstDash val="solid"/>
-                      <a:round/>
-                      <a:headEnd type="none" w="med" len="med"/>
-                      <a:tailEnd type="none" w="med" len="med"/>
-                    </a:lnL>
-                    <a:lnR w="12700" cap="flat" cmpd="sng" algn="ctr">
-                      <a:solidFill>
-                        <a:srgbClr val="3A4694"/>
-                      </a:solidFill>
-                      <a:prstDash val="solid"/>
-                      <a:round/>
-                      <a:headEnd type="none" w="med" len="med"/>
-                      <a:tailEnd type="none" w="med" len="med"/>
-                    </a:lnR>
-                    <a:lnT w="12700" cap="flat" cmpd="sng" algn="ctr">
-                      <a:solidFill>
-                        <a:srgbClr val="3A4694"/>
-                      </a:solidFill>
-                      <a:prstDash val="solid"/>
-                      <a:round/>
-                      <a:headEnd type="none" w="med" len="med"/>
-                      <a:tailEnd type="none" w="med" len="med"/>
-                    </a:lnT>
-                    <a:lnB w="12700" cap="flat" cmpd="sng" algn="ctr">
-                      <a:solidFill>
-                        <a:srgbClr val="3A4694"/>
-                      </a:solidFill>
-                      <a:prstDash val="solid"/>
-                      <a:round/>
-                      <a:headEnd type="none" w="med" len="med"/>
-                      <a:tailEnd type="none" w="med" len="med"/>
-                    </a:lnB>
-                    <a:solidFill>
-                      <a:srgbClr val="141B45"/>
-                    </a:solidFill>
-                  </a:tcPr>
-                </a:tc>
-              </a:tr>
-              <a:tr h="566928">
-                <a:tc>
-                  <a:txBody>
-                    <a:bodyPr/>
-                    <a:lstStyle/>
-                    <a:p>
-                      <a:pPr indent="0" marL="0">
-                        <a:buNone/>
-                      </a:pPr>
-                      <a:r>
-                        <a:rPr lang="en-US" sz="1500" dirty="0">
-                          <a:solidFill>
-                            <a:srgbClr val="FFFFFF"/>
-                          </a:solidFill>
-                          <a:latin typeface="Calibri" pitchFamily="34" charset="0"/>
-                          <a:ea typeface="Calibri" pitchFamily="34" charset="-122"/>
-                          <a:cs typeface="Calibri" pitchFamily="34" charset="-120"/>
-                        </a:rPr>
-                        <a:t>2</a:t>
-                      </a:r>
-                      <a:endParaRPr lang="en-US" sz="1500" dirty="0">
-                        <a:latin typeface="Calibri" charset="0"/>
-                        <a:ea typeface="Calibri" charset="0"/>
-                        <a:cs typeface="Calibri" charset="0"/>
-                      </a:endParaRPr>
-                    </a:p>
-                  </a:txBody>
-                  <a:tcPr marL="91440" marR="91440" marT="45720" marB="45720" anchor="ctr">
-                    <a:lnL w="12700" cap="flat" cmpd="sng" algn="ctr">
-                      <a:solidFill>
-                        <a:srgbClr val="3A4694"/>
-                      </a:solidFill>
-                      <a:prstDash val="solid"/>
-                      <a:round/>
-                      <a:headEnd type="none" w="med" len="med"/>
-                      <a:tailEnd type="none" w="med" len="med"/>
-                    </a:lnL>
-                    <a:lnR w="12700" cap="flat" cmpd="sng" algn="ctr">
-                      <a:solidFill>
-                        <a:srgbClr val="3A4694"/>
-                      </a:solidFill>
-                      <a:prstDash val="solid"/>
-                      <a:round/>
-                      <a:headEnd type="none" w="med" len="med"/>
-                      <a:tailEnd type="none" w="med" len="med"/>
-                    </a:lnR>
-                    <a:lnT w="12700" cap="flat" cmpd="sng" algn="ctr">
-                      <a:solidFill>
-                        <a:srgbClr val="3A4694"/>
-                      </a:solidFill>
-                      <a:prstDash val="solid"/>
-                      <a:round/>
-                      <a:headEnd type="none" w="med" len="med"/>
-                      <a:tailEnd type="none" w="med" len="med"/>
-                    </a:lnT>
-                    <a:lnB w="12700" cap="flat" cmpd="sng" algn="ctr">
-                      <a:solidFill>
-                        <a:srgbClr val="3A4694"/>
-                      </a:solidFill>
-                      <a:prstDash val="solid"/>
-                      <a:round/>
-                      <a:headEnd type="none" w="med" len="med"/>
-                      <a:tailEnd type="none" w="med" len="med"/>
-                    </a:lnB>
-                    <a:solidFill>
-                      <a:srgbClr val="141B45"/>
-                    </a:solidFill>
-                  </a:tcPr>
-                </a:tc>
-                <a:tc>
-                  <a:txBody>
-                    <a:bodyPr/>
-                    <a:lstStyle/>
-                    <a:p>
-                      <a:pPr indent="0" marL="0">
-                        <a:buNone/>
-                      </a:pPr>
-                      <a:r>
-                        <a:rPr lang="en-US" sz="1500" dirty="0">
-                          <a:solidFill>
-                            <a:srgbClr val="FFFFFF"/>
-                          </a:solidFill>
-                          <a:latin typeface="Calibri" pitchFamily="34" charset="0"/>
-                          <a:ea typeface="Calibri" pitchFamily="34" charset="-122"/>
-                          <a:cs typeface="Calibri" pitchFamily="34" charset="-120"/>
-                        </a:rPr>
-                        <a:t>Objectives and Scope of the Proposed Work</a:t>
-                      </a:r>
-                      <a:endParaRPr lang="en-US" sz="1500" dirty="0">
-                        <a:latin typeface="Calibri" charset="0"/>
-                        <a:ea typeface="Calibri" charset="0"/>
-                        <a:cs typeface="Calibri" charset="0"/>
-                      </a:endParaRPr>
-                    </a:p>
-                  </a:txBody>
-                  <a:tcPr marL="91440" marR="91440" marT="45720" marB="45720" anchor="ctr">
-                    <a:lnL w="12700" cap="flat" cmpd="sng" algn="ctr">
-                      <a:solidFill>
-                        <a:srgbClr val="3A4694"/>
-                      </a:solidFill>
-                      <a:prstDash val="solid"/>
-                      <a:round/>
-                      <a:headEnd type="none" w="med" len="med"/>
-                      <a:tailEnd type="none" w="med" len="med"/>
-                    </a:lnL>
-                    <a:lnR w="12700" cap="flat" cmpd="sng" algn="ctr">
-                      <a:solidFill>
-                        <a:srgbClr val="3A4694"/>
-                      </a:solidFill>
-                      <a:prstDash val="solid"/>
-                      <a:round/>
-                      <a:headEnd type="none" w="med" len="med"/>
-                      <a:tailEnd type="none" w="med" len="med"/>
-                    </a:lnR>
-                    <a:lnT w="12700" cap="flat" cmpd="sng" algn="ctr">
-                      <a:solidFill>
-                        <a:srgbClr val="3A4694"/>
-                      </a:solidFill>
-                      <a:prstDash val="solid"/>
-                      <a:round/>
-                      <a:headEnd type="none" w="med" len="med"/>
-                      <a:tailEnd type="none" w="med" len="med"/>
-                    </a:lnT>
-                    <a:lnB w="12700" cap="flat" cmpd="sng" algn="ctr">
-                      <a:solidFill>
-                        <a:srgbClr val="3A4694"/>
-                      </a:solidFill>
-                      <a:prstDash val="solid"/>
-                      <a:round/>
-                      <a:headEnd type="none" w="med" len="med"/>
-                      <a:tailEnd type="none" w="med" len="med"/>
-                    </a:lnB>
-                    <a:solidFill>
-                      <a:srgbClr val="141B45"/>
-                    </a:solidFill>
-                  </a:tcPr>
-                </a:tc>
-                <a:tc>
-                  <a:txBody>
-                    <a:bodyPr/>
-                    <a:lstStyle/>
-                    <a:p>
-                      <a:pPr algn="ctr" indent="0" marL="0">
-                        <a:buNone/>
-                      </a:pPr>
-                      <a:r>
-                        <a:rPr lang="en-US" sz="1500" b="1" dirty="0">
-                          <a:solidFill>
-                            <a:srgbClr val="FFFFFF"/>
-                          </a:solidFill>
-                          <a:latin typeface="Calibri" pitchFamily="34" charset="0"/>
-                          <a:ea typeface="Calibri" pitchFamily="34" charset="-122"/>
-                          <a:cs typeface="Calibri" pitchFamily="34" charset="-120"/>
-                        </a:rPr>
-                        <a:t>6</a:t>
-                      </a:r>
-                      <a:endParaRPr lang="en-US" sz="1500" dirty="0">
-                        <a:latin typeface="Calibri" charset="0"/>
-                        <a:ea typeface="Calibri" charset="0"/>
-                        <a:cs typeface="Calibri" charset="0"/>
-                      </a:endParaRPr>
-                    </a:p>
-                  </a:txBody>
-                  <a:tcPr marL="91440" marR="91440" marT="45720" marB="45720" anchor="ctr">
-                    <a:lnL w="12700" cap="flat" cmpd="sng" algn="ctr">
-                      <a:solidFill>
-                        <a:srgbClr val="3A4694"/>
-                      </a:solidFill>
-                      <a:prstDash val="solid"/>
-                      <a:round/>
-                      <a:headEnd type="none" w="med" len="med"/>
-                      <a:tailEnd type="none" w="med" len="med"/>
-                    </a:lnL>
-                    <a:lnR w="12700" cap="flat" cmpd="sng" algn="ctr">
-                      <a:solidFill>
-                        <a:srgbClr val="3A4694"/>
-                      </a:solidFill>
-                      <a:prstDash val="solid"/>
-                      <a:round/>
-                      <a:headEnd type="none" w="med" len="med"/>
-                      <a:tailEnd type="none" w="med" len="med"/>
-                    </a:lnR>
-                    <a:lnT w="12700" cap="flat" cmpd="sng" algn="ctr">
-                      <a:solidFill>
-                        <a:srgbClr val="3A4694"/>
-                      </a:solidFill>
-                      <a:prstDash val="solid"/>
-                      <a:round/>
-                      <a:headEnd type="none" w="med" len="med"/>
-                      <a:tailEnd type="none" w="med" len="med"/>
-                    </a:lnT>
-                    <a:lnB w="12700" cap="flat" cmpd="sng" algn="ctr">
-                      <a:solidFill>
-                        <a:srgbClr val="3A4694"/>
-                      </a:solidFill>
-                      <a:prstDash val="solid"/>
-                      <a:round/>
-                      <a:headEnd type="none" w="med" len="med"/>
-                      <a:tailEnd type="none" w="med" len="med"/>
-                    </a:lnB>
-                    <a:solidFill>
-                      <a:srgbClr val="141B45"/>
-                    </a:solidFill>
-                  </a:tcPr>
-                </a:tc>
-              </a:tr>
-              <a:tr h="566928">
-                <a:tc>
-                  <a:txBody>
-                    <a:bodyPr/>
-                    <a:lstStyle/>
-                    <a:p>
-                      <a:pPr indent="0" marL="0">
-                        <a:buNone/>
-                      </a:pPr>
-                      <a:r>
-                        <a:rPr lang="en-US" sz="1500" dirty="0">
-                          <a:solidFill>
-                            <a:srgbClr val="FFFFFF"/>
-                          </a:solidFill>
-                          <a:latin typeface="Calibri" pitchFamily="34" charset="0"/>
-                          <a:ea typeface="Calibri" pitchFamily="34" charset="-122"/>
-                          <a:cs typeface="Calibri" pitchFamily="34" charset="-120"/>
-                        </a:rPr>
-                        <a:t>3</a:t>
-                      </a:r>
-                      <a:endParaRPr lang="en-US" sz="1500" dirty="0">
-                        <a:latin typeface="Calibri" charset="0"/>
-                        <a:ea typeface="Calibri" charset="0"/>
-                        <a:cs typeface="Calibri" charset="0"/>
-                      </a:endParaRPr>
-                    </a:p>
-                  </a:txBody>
-                  <a:tcPr marL="91440" marR="91440" marT="45720" marB="45720" anchor="ctr">
-                    <a:lnL w="12700" cap="flat" cmpd="sng" algn="ctr">
-                      <a:solidFill>
-                        <a:srgbClr val="3A4694"/>
-                      </a:solidFill>
-                      <a:prstDash val="solid"/>
-                      <a:round/>
-                      <a:headEnd type="none" w="med" len="med"/>
-                      <a:tailEnd type="none" w="med" len="med"/>
-                    </a:lnL>
-                    <a:lnR w="12700" cap="flat" cmpd="sng" algn="ctr">
-                      <a:solidFill>
-                        <a:srgbClr val="3A4694"/>
-                      </a:solidFill>
-                      <a:prstDash val="solid"/>
-                      <a:round/>
-                      <a:headEnd type="none" w="med" len="med"/>
-                      <a:tailEnd type="none" w="med" len="med"/>
-                    </a:lnR>
-                    <a:lnT w="12700" cap="flat" cmpd="sng" algn="ctr">
-                      <a:solidFill>
-                        <a:srgbClr val="3A4694"/>
-                      </a:solidFill>
-                      <a:prstDash val="solid"/>
-                      <a:round/>
-                      <a:headEnd type="none" w="med" len="med"/>
-                      <a:tailEnd type="none" w="med" len="med"/>
-                    </a:lnT>
-                    <a:lnB w="12700" cap="flat" cmpd="sng" algn="ctr">
-                      <a:solidFill>
-                        <a:srgbClr val="3A4694"/>
-                      </a:solidFill>
-                      <a:prstDash val="solid"/>
-                      <a:round/>
-                      <a:headEnd type="none" w="med" len="med"/>
-                      <a:tailEnd type="none" w="med" len="med"/>
-                    </a:lnB>
-                    <a:solidFill>
-                      <a:srgbClr val="141B45"/>
-                    </a:solidFill>
-                  </a:tcPr>
-                </a:tc>
-                <a:tc>
-                  <a:txBody>
-                    <a:bodyPr/>
-                    <a:lstStyle/>
-                    <a:p>
-                      <a:pPr indent="0" marL="0">
-                        <a:buNone/>
-                      </a:pPr>
-                      <a:r>
-                        <a:rPr lang="en-US" sz="1500" dirty="0">
-                          <a:solidFill>
-                            <a:srgbClr val="FFFFFF"/>
-                          </a:solidFill>
-                          <a:latin typeface="Calibri" pitchFamily="34" charset="0"/>
-                          <a:ea typeface="Calibri" pitchFamily="34" charset="-122"/>
-                          <a:cs typeface="Calibri" pitchFamily="34" charset="-120"/>
-                        </a:rPr>
-                        <a:t>Novel Idea</a:t>
-                      </a:r>
-                      <a:endParaRPr lang="en-US" sz="1500" dirty="0">
-                        <a:latin typeface="Calibri" charset="0"/>
-                        <a:ea typeface="Calibri" charset="0"/>
-                        <a:cs typeface="Calibri" charset="0"/>
-                      </a:endParaRPr>
-                    </a:p>
-                  </a:txBody>
-                  <a:tcPr marL="91440" marR="91440" marT="45720" marB="45720" anchor="ctr">
-                    <a:lnL w="12700" cap="flat" cmpd="sng" algn="ctr">
-                      <a:solidFill>
-                        <a:srgbClr val="3A4694"/>
-                      </a:solidFill>
-                      <a:prstDash val="solid"/>
-                      <a:round/>
-                      <a:headEnd type="none" w="med" len="med"/>
-                      <a:tailEnd type="none" w="med" len="med"/>
-                    </a:lnL>
-                    <a:lnR w="12700" cap="flat" cmpd="sng" algn="ctr">
-                      <a:solidFill>
-                        <a:srgbClr val="3A4694"/>
-                      </a:solidFill>
-                      <a:prstDash val="solid"/>
-                      <a:round/>
-                      <a:headEnd type="none" w="med" len="med"/>
-                      <a:tailEnd type="none" w="med" len="med"/>
-                    </a:lnR>
-                    <a:lnT w="12700" cap="flat" cmpd="sng" algn="ctr">
-                      <a:solidFill>
-                        <a:srgbClr val="3A4694"/>
-                      </a:solidFill>
-                      <a:prstDash val="solid"/>
-                      <a:round/>
-                      <a:headEnd type="none" w="med" len="med"/>
-                      <a:tailEnd type="none" w="med" len="med"/>
-                    </a:lnT>
-                    <a:lnB w="12700" cap="flat" cmpd="sng" algn="ctr">
-                      <a:solidFill>
-                        <a:srgbClr val="3A4694"/>
-                      </a:solidFill>
-                      <a:prstDash val="solid"/>
-                      <a:round/>
-                      <a:headEnd type="none" w="med" len="med"/>
-                      <a:tailEnd type="none" w="med" len="med"/>
-                    </a:lnB>
-                    <a:solidFill>
-                      <a:srgbClr val="141B45"/>
-                    </a:solidFill>
-                  </a:tcPr>
-                </a:tc>
-                <a:tc>
-                  <a:txBody>
-                    <a:bodyPr/>
-                    <a:lstStyle/>
-                    <a:p>
-                      <a:pPr algn="ctr" indent="0" marL="0">
-                        <a:buNone/>
-                      </a:pPr>
-                      <a:r>
-                        <a:rPr lang="en-US" sz="1500" b="1" dirty="0">
-                          <a:solidFill>
-                            <a:srgbClr val="FFFFFF"/>
-                          </a:solidFill>
-                          <a:latin typeface="Calibri" pitchFamily="34" charset="0"/>
-                          <a:ea typeface="Calibri" pitchFamily="34" charset="-122"/>
-                          <a:cs typeface="Calibri" pitchFamily="34" charset="-120"/>
-                        </a:rPr>
-                        <a:t>2</a:t>
-                      </a:r>
-                      <a:endParaRPr lang="en-US" sz="1500" dirty="0">
-                        <a:latin typeface="Calibri" charset="0"/>
-                        <a:ea typeface="Calibri" charset="0"/>
-                        <a:cs typeface="Calibri" charset="0"/>
-                      </a:endParaRPr>
-                    </a:p>
-                  </a:txBody>
-                  <a:tcPr marL="91440" marR="91440" marT="45720" marB="45720" anchor="ctr">
-                    <a:lnL w="12700" cap="flat" cmpd="sng" algn="ctr">
-                      <a:solidFill>
-                        <a:srgbClr val="3A4694"/>
-                      </a:solidFill>
-                      <a:prstDash val="solid"/>
-                      <a:round/>
-                      <a:headEnd type="none" w="med" len="med"/>
-                      <a:tailEnd type="none" w="med" len="med"/>
-                    </a:lnL>
-                    <a:lnR w="12700" cap="flat" cmpd="sng" algn="ctr">
-                      <a:solidFill>
-                        <a:srgbClr val="3A4694"/>
-                      </a:solidFill>
-                      <a:prstDash val="solid"/>
-                      <a:round/>
-                      <a:headEnd type="none" w="med" len="med"/>
-                      <a:tailEnd type="none" w="med" len="med"/>
-                    </a:lnR>
-                    <a:lnT w="12700" cap="flat" cmpd="sng" algn="ctr">
-                      <a:solidFill>
-                        <a:srgbClr val="3A4694"/>
-                      </a:solidFill>
-                      <a:prstDash val="solid"/>
-                      <a:round/>
-                      <a:headEnd type="none" w="med" len="med"/>
-                      <a:tailEnd type="none" w="med" len="med"/>
-                    </a:lnT>
-                    <a:lnB w="12700" cap="flat" cmpd="sng" algn="ctr">
-                      <a:solidFill>
-                        <a:srgbClr val="3A4694"/>
-                      </a:solidFill>
-                      <a:prstDash val="solid"/>
-                      <a:round/>
-                      <a:headEnd type="none" w="med" len="med"/>
-                      <a:tailEnd type="none" w="med" len="med"/>
-                    </a:lnB>
-                    <a:solidFill>
-                      <a:srgbClr val="141B45"/>
-                    </a:solidFill>
-                  </a:tcPr>
-                </a:tc>
-              </a:tr>
-              <a:tr h="566928">
-                <a:tc>
-                  <a:txBody>
-                    <a:bodyPr/>
-                    <a:lstStyle/>
-                    <a:p>
-                      <a:pPr indent="0" marL="0">
-                        <a:buNone/>
-                      </a:pPr>
-                      <a:r>
-                        <a:rPr lang="en-US" sz="1500" dirty="0">
-                          <a:solidFill>
-                            <a:srgbClr val="FFFFFF"/>
-                          </a:solidFill>
-                          <a:latin typeface="Calibri" pitchFamily="34" charset="0"/>
-                          <a:ea typeface="Calibri" pitchFamily="34" charset="-122"/>
-                          <a:cs typeface="Calibri" pitchFamily="34" charset="-120"/>
-                        </a:rPr>
-                        <a:t>4</a:t>
-                      </a:r>
-                      <a:endParaRPr lang="en-US" sz="1500" dirty="0">
-                        <a:latin typeface="Calibri" charset="0"/>
-                        <a:ea typeface="Calibri" charset="0"/>
-                        <a:cs typeface="Calibri" charset="0"/>
-                      </a:endParaRPr>
-                    </a:p>
-                  </a:txBody>
-                  <a:tcPr marL="91440" marR="91440" marT="45720" marB="45720" anchor="ctr">
-                    <a:lnL w="12700" cap="flat" cmpd="sng" algn="ctr">
-                      <a:solidFill>
-                        <a:srgbClr val="3A4694"/>
-                      </a:solidFill>
-                      <a:prstDash val="solid"/>
-                      <a:round/>
-                      <a:headEnd type="none" w="med" len="med"/>
-                      <a:tailEnd type="none" w="med" len="med"/>
-                    </a:lnL>
-                    <a:lnR w="12700" cap="flat" cmpd="sng" algn="ctr">
-                      <a:solidFill>
-                        <a:srgbClr val="3A4694"/>
-                      </a:solidFill>
-                      <a:prstDash val="solid"/>
-                      <a:round/>
-                      <a:headEnd type="none" w="med" len="med"/>
-                      <a:tailEnd type="none" w="med" len="med"/>
-                    </a:lnR>
-                    <a:lnT w="12700" cap="flat" cmpd="sng" algn="ctr">
-                      <a:solidFill>
-                        <a:srgbClr val="3A4694"/>
-                      </a:solidFill>
-                      <a:prstDash val="solid"/>
-                      <a:round/>
-                      <a:headEnd type="none" w="med" len="med"/>
-                      <a:tailEnd type="none" w="med" len="med"/>
-                    </a:lnT>
-                    <a:lnB w="12700" cap="flat" cmpd="sng" algn="ctr">
-                      <a:solidFill>
-                        <a:srgbClr val="3A4694"/>
-                      </a:solidFill>
-                      <a:prstDash val="solid"/>
-                      <a:round/>
-                      <a:headEnd type="none" w="med" len="med"/>
-                      <a:tailEnd type="none" w="med" len="med"/>
-                    </a:lnB>
-                    <a:solidFill>
-                      <a:srgbClr val="141B45"/>
-                    </a:solidFill>
-                  </a:tcPr>
-                </a:tc>
-                <a:tc>
-                  <a:txBody>
-                    <a:bodyPr/>
-                    <a:lstStyle/>
-                    <a:p>
-                      <a:pPr indent="0" marL="0">
-                        <a:buNone/>
-                      </a:pPr>
-                      <a:r>
-                        <a:rPr lang="en-US" sz="1500" dirty="0">
-                          <a:solidFill>
-                            <a:srgbClr val="FFFFFF"/>
-                          </a:solidFill>
-                          <a:latin typeface="Calibri" pitchFamily="34" charset="0"/>
-                          <a:ea typeface="Calibri" pitchFamily="34" charset="-122"/>
-                          <a:cs typeface="Calibri" pitchFamily="34" charset="-120"/>
-                        </a:rPr>
-                        <a:t>Detailed Design</a:t>
-                      </a:r>
-                      <a:endParaRPr lang="en-US" sz="1500" dirty="0">
-                        <a:latin typeface="Calibri" charset="0"/>
-                        <a:ea typeface="Calibri" charset="0"/>
-                        <a:cs typeface="Calibri" charset="0"/>
-                      </a:endParaRPr>
-                    </a:p>
-                  </a:txBody>
-                  <a:tcPr marL="91440" marR="91440" marT="45720" marB="45720" anchor="ctr">
-                    <a:lnL w="12700" cap="flat" cmpd="sng" algn="ctr">
-                      <a:solidFill>
-                        <a:srgbClr val="3A4694"/>
-                      </a:solidFill>
-                      <a:prstDash val="solid"/>
-                      <a:round/>
-                      <a:headEnd type="none" w="med" len="med"/>
-                      <a:tailEnd type="none" w="med" len="med"/>
-                    </a:lnL>
-                    <a:lnR w="12700" cap="flat" cmpd="sng" algn="ctr">
-                      <a:solidFill>
-                        <a:srgbClr val="3A4694"/>
-                      </a:solidFill>
-                      <a:prstDash val="solid"/>
-                      <a:round/>
-                      <a:headEnd type="none" w="med" len="med"/>
-                      <a:tailEnd type="none" w="med" len="med"/>
-                    </a:lnR>
-                    <a:lnT w="12700" cap="flat" cmpd="sng" algn="ctr">
-                      <a:solidFill>
-                        <a:srgbClr val="3A4694"/>
-                      </a:solidFill>
-                      <a:prstDash val="solid"/>
-                      <a:round/>
-                      <a:headEnd type="none" w="med" len="med"/>
-                      <a:tailEnd type="none" w="med" len="med"/>
-                    </a:lnT>
-                    <a:lnB w="12700" cap="flat" cmpd="sng" algn="ctr">
-                      <a:solidFill>
-                        <a:srgbClr val="3A4694"/>
-                      </a:solidFill>
-                      <a:prstDash val="solid"/>
-                      <a:round/>
-                      <a:headEnd type="none" w="med" len="med"/>
-                      <a:tailEnd type="none" w="med" len="med"/>
-                    </a:lnB>
-                    <a:solidFill>
-                      <a:srgbClr val="141B45"/>
-                    </a:solidFill>
-                  </a:tcPr>
-                </a:tc>
-                <a:tc>
-                  <a:txBody>
-                    <a:bodyPr/>
-                    <a:lstStyle/>
-                    <a:p>
-                      <a:pPr algn="ctr" indent="0" marL="0">
-                        <a:buNone/>
-                      </a:pPr>
-                      <a:r>
-                        <a:rPr lang="en-US" sz="1500" b="1" dirty="0">
-                          <a:solidFill>
-                            <a:srgbClr val="FFFFFF"/>
-                          </a:solidFill>
-                          <a:latin typeface="Calibri" pitchFamily="34" charset="0"/>
-                          <a:ea typeface="Calibri" pitchFamily="34" charset="-122"/>
-                          <a:cs typeface="Calibri" pitchFamily="34" charset="-120"/>
-                        </a:rPr>
-                        <a:t>5</a:t>
-                      </a:r>
-                      <a:endParaRPr lang="en-US" sz="1500" dirty="0">
-                        <a:latin typeface="Calibri" charset="0"/>
-                        <a:ea typeface="Calibri" charset="0"/>
-                        <a:cs typeface="Calibri" charset="0"/>
-                      </a:endParaRPr>
-                    </a:p>
-                  </a:txBody>
-                  <a:tcPr marL="91440" marR="91440" marT="45720" marB="45720" anchor="ctr">
-                    <a:lnL w="12700" cap="flat" cmpd="sng" algn="ctr">
-                      <a:solidFill>
-                        <a:srgbClr val="3A4694"/>
-                      </a:solidFill>
-                      <a:prstDash val="solid"/>
-                      <a:round/>
-                      <a:headEnd type="none" w="med" len="med"/>
-                      <a:tailEnd type="none" w="med" len="med"/>
-                    </a:lnL>
-                    <a:lnR w="12700" cap="flat" cmpd="sng" algn="ctr">
-                      <a:solidFill>
-                        <a:srgbClr val="3A4694"/>
-                      </a:solidFill>
-                      <a:prstDash val="solid"/>
-                      <a:round/>
-                      <a:headEnd type="none" w="med" len="med"/>
-                      <a:tailEnd type="none" w="med" len="med"/>
-                    </a:lnR>
-                    <a:lnT w="12700" cap="flat" cmpd="sng" algn="ctr">
-                      <a:solidFill>
-                        <a:srgbClr val="3A4694"/>
-                      </a:solidFill>
-                      <a:prstDash val="solid"/>
-                      <a:round/>
-                      <a:headEnd type="none" w="med" len="med"/>
-                      <a:tailEnd type="none" w="med" len="med"/>
-                    </a:lnT>
-                    <a:lnB w="12700" cap="flat" cmpd="sng" algn="ctr">
-                      <a:solidFill>
-                        <a:srgbClr val="3A4694"/>
-                      </a:solidFill>
-                      <a:prstDash val="solid"/>
-                      <a:round/>
-                      <a:headEnd type="none" w="med" len="med"/>
-                      <a:tailEnd type="none" w="med" len="med"/>
-                    </a:lnB>
-                    <a:solidFill>
-                      <a:srgbClr val="141B45"/>
-                    </a:solidFill>
-                  </a:tcPr>
-                </a:tc>
-              </a:tr>
-              <a:tr h="566928">
-                <a:tc>
-                  <a:txBody>
-                    <a:bodyPr/>
-                    <a:lstStyle/>
-                    <a:p>
-                      <a:pPr indent="0" marL="0">
-                        <a:buNone/>
-                      </a:pPr>
-                      <a:r>
-                        <a:rPr lang="en-US" sz="1500" dirty="0">
-                          <a:solidFill>
-                            <a:srgbClr val="FFFFFF"/>
-                          </a:solidFill>
-                          <a:latin typeface="Calibri" pitchFamily="34" charset="0"/>
-                          <a:ea typeface="Calibri" pitchFamily="34" charset="-122"/>
-                          <a:cs typeface="Calibri" pitchFamily="34" charset="-120"/>
-                        </a:rPr>
-                        <a:t>5</a:t>
-                      </a:r>
-                      <a:endParaRPr lang="en-US" sz="1500" dirty="0">
-                        <a:latin typeface="Calibri" charset="0"/>
-                        <a:ea typeface="Calibri" charset="0"/>
-                        <a:cs typeface="Calibri" charset="0"/>
-                      </a:endParaRPr>
-                    </a:p>
-                  </a:txBody>
-                  <a:tcPr marL="91440" marR="91440" marT="45720" marB="45720" anchor="ctr">
-                    <a:lnL w="12700" cap="flat" cmpd="sng" algn="ctr">
-                      <a:solidFill>
-                        <a:srgbClr val="3A4694"/>
-                      </a:solidFill>
-                      <a:prstDash val="solid"/>
-                      <a:round/>
-                      <a:headEnd type="none" w="med" len="med"/>
-                      <a:tailEnd type="none" w="med" len="med"/>
-                    </a:lnL>
-                    <a:lnR w="12700" cap="flat" cmpd="sng" algn="ctr">
-                      <a:solidFill>
-                        <a:srgbClr val="3A4694"/>
-                      </a:solidFill>
-                      <a:prstDash val="solid"/>
-                      <a:round/>
-                      <a:headEnd type="none" w="med" len="med"/>
-                      <a:tailEnd type="none" w="med" len="med"/>
-                    </a:lnR>
-                    <a:lnT w="12700" cap="flat" cmpd="sng" algn="ctr">
-                      <a:solidFill>
-                        <a:srgbClr val="3A4694"/>
-                      </a:solidFill>
-                      <a:prstDash val="solid"/>
-                      <a:round/>
-                      <a:headEnd type="none" w="med" len="med"/>
-                      <a:tailEnd type="none" w="med" len="med"/>
-                    </a:lnT>
-                    <a:lnB w="12700" cap="flat" cmpd="sng" algn="ctr">
-                      <a:solidFill>
-                        <a:srgbClr val="3A4694"/>
-                      </a:solidFill>
-                      <a:prstDash val="solid"/>
-                      <a:round/>
-                      <a:headEnd type="none" w="med" len="med"/>
-                      <a:tailEnd type="none" w="med" len="med"/>
-                    </a:lnB>
-                    <a:solidFill>
-                      <a:srgbClr val="141B45"/>
-                    </a:solidFill>
-                  </a:tcPr>
-                </a:tc>
-                <a:tc>
-                  <a:txBody>
-                    <a:bodyPr/>
-                    <a:lstStyle/>
-                    <a:p>
-                      <a:pPr indent="0" marL="0">
-                        <a:buNone/>
-                      </a:pPr>
-                      <a:r>
-                        <a:rPr lang="en-US" sz="1500" dirty="0">
-                          <a:solidFill>
-                            <a:srgbClr val="FFFFFF"/>
-                          </a:solidFill>
-                          <a:latin typeface="Calibri" pitchFamily="34" charset="0"/>
-                          <a:ea typeface="Calibri" pitchFamily="34" charset="-122"/>
-                          <a:cs typeface="Calibri" pitchFamily="34" charset="-120"/>
-                        </a:rPr>
-                        <a:t>Solution Methodology &amp; Modules Description</a:t>
-                      </a:r>
-                      <a:endParaRPr lang="en-US" sz="1500" dirty="0">
-                        <a:latin typeface="Calibri" charset="0"/>
-                        <a:ea typeface="Calibri" charset="0"/>
-                        <a:cs typeface="Calibri" charset="0"/>
-                      </a:endParaRPr>
-                    </a:p>
-                  </a:txBody>
-                  <a:tcPr marL="91440" marR="91440" marT="45720" marB="45720" anchor="ctr">
-                    <a:lnL w="12700" cap="flat" cmpd="sng" algn="ctr">
-                      <a:solidFill>
-                        <a:srgbClr val="3A4694"/>
-                      </a:solidFill>
-                      <a:prstDash val="solid"/>
-                      <a:round/>
-                      <a:headEnd type="none" w="med" len="med"/>
-                      <a:tailEnd type="none" w="med" len="med"/>
-                    </a:lnL>
-                    <a:lnR w="12700" cap="flat" cmpd="sng" algn="ctr">
-                      <a:solidFill>
-                        <a:srgbClr val="3A4694"/>
-                      </a:solidFill>
-                      <a:prstDash val="solid"/>
-                      <a:round/>
-                      <a:headEnd type="none" w="med" len="med"/>
-                      <a:tailEnd type="none" w="med" len="med"/>
-                    </a:lnR>
-                    <a:lnT w="12700" cap="flat" cmpd="sng" algn="ctr">
-                      <a:solidFill>
-                        <a:srgbClr val="3A4694"/>
-                      </a:solidFill>
-                      <a:prstDash val="solid"/>
-                      <a:round/>
-                      <a:headEnd type="none" w="med" len="med"/>
-                      <a:tailEnd type="none" w="med" len="med"/>
-                    </a:lnT>
-                    <a:lnB w="12700" cap="flat" cmpd="sng" algn="ctr">
-                      <a:solidFill>
-                        <a:srgbClr val="3A4694"/>
-                      </a:solidFill>
-                      <a:prstDash val="solid"/>
-                      <a:round/>
-                      <a:headEnd type="none" w="med" len="med"/>
-                      <a:tailEnd type="none" w="med" len="med"/>
-                    </a:lnB>
-                    <a:solidFill>
-                      <a:srgbClr val="141B45"/>
-                    </a:solidFill>
-                  </a:tcPr>
-                </a:tc>
-                <a:tc>
-                  <a:txBody>
-                    <a:bodyPr/>
-                    <a:lstStyle/>
-                    <a:p>
-                      <a:pPr algn="ctr" indent="0" marL="0">
-                        <a:buNone/>
-                      </a:pPr>
-                      <a:r>
-                        <a:rPr lang="en-US" sz="1500" b="1" dirty="0">
-                          <a:solidFill>
-                            <a:srgbClr val="FFFFFF"/>
-                          </a:solidFill>
-                          <a:latin typeface="Calibri" pitchFamily="34" charset="0"/>
-                          <a:ea typeface="Calibri" pitchFamily="34" charset="-122"/>
-                          <a:cs typeface="Calibri" pitchFamily="34" charset="-120"/>
-                        </a:rPr>
-                        <a:t>13</a:t>
-                      </a:r>
-                      <a:endParaRPr lang="en-US" sz="1500" dirty="0">
-                        <a:latin typeface="Calibri" charset="0"/>
-                        <a:ea typeface="Calibri" charset="0"/>
-                        <a:cs typeface="Calibri" charset="0"/>
-                      </a:endParaRPr>
-                    </a:p>
-                  </a:txBody>
-                  <a:tcPr marL="91440" marR="91440" marT="45720" marB="45720" anchor="ctr">
-                    <a:lnL w="12700" cap="flat" cmpd="sng" algn="ctr">
-                      <a:solidFill>
-                        <a:srgbClr val="3A4694"/>
-                      </a:solidFill>
-                      <a:prstDash val="solid"/>
-                      <a:round/>
-                      <a:headEnd type="none" w="med" len="med"/>
-                      <a:tailEnd type="none" w="med" len="med"/>
-                    </a:lnL>
-                    <a:lnR w="12700" cap="flat" cmpd="sng" algn="ctr">
-                      <a:solidFill>
-                        <a:srgbClr val="3A4694"/>
-                      </a:solidFill>
-                      <a:prstDash val="solid"/>
-                      <a:round/>
-                      <a:headEnd type="none" w="med" len="med"/>
-                      <a:tailEnd type="none" w="med" len="med"/>
-                    </a:lnR>
-                    <a:lnT w="12700" cap="flat" cmpd="sng" algn="ctr">
-                      <a:solidFill>
-                        <a:srgbClr val="3A4694"/>
-                      </a:solidFill>
-                      <a:prstDash val="solid"/>
-                      <a:round/>
-                      <a:headEnd type="none" w="med" len="med"/>
-                      <a:tailEnd type="none" w="med" len="med"/>
-                    </a:lnT>
-                    <a:lnB w="12700" cap="flat" cmpd="sng" algn="ctr">
-                      <a:solidFill>
-                        <a:srgbClr val="3A4694"/>
-                      </a:solidFill>
-                      <a:prstDash val="solid"/>
-                      <a:round/>
-                      <a:headEnd type="none" w="med" len="med"/>
-                      <a:tailEnd type="none" w="med" len="med"/>
-                    </a:lnB>
-                    <a:solidFill>
-                      <a:srgbClr val="141B45"/>
-                    </a:solidFill>
-                  </a:tcPr>
-                </a:tc>
-              </a:tr>
-              <a:tr h="566928">
-                <a:tc>
-                  <a:txBody>
-                    <a:bodyPr/>
-                    <a:lstStyle/>
-                    <a:p>
-                      <a:pPr indent="0" marL="0">
-                        <a:buNone/>
-                      </a:pPr>
-                      <a:endParaRPr lang="en-US" sz="1500" dirty="0">
-                        <a:latin typeface="Calibri" charset="0"/>
-                        <a:ea typeface="Calibri" charset="0"/>
-                        <a:cs typeface="Calibri" charset="0"/>
-                      </a:endParaRPr>
-                    </a:p>
-                  </a:txBody>
-                  <a:tcPr marL="91440" marR="91440" marT="45720" marB="45720" anchor="ctr">
-                    <a:lnL w="12700" cap="flat" cmpd="sng" algn="ctr">
-                      <a:solidFill>
-                        <a:srgbClr val="3A4694"/>
-                      </a:solidFill>
-                      <a:prstDash val="solid"/>
-                      <a:round/>
-                      <a:headEnd type="none" w="med" len="med"/>
-                      <a:tailEnd type="none" w="med" len="med"/>
-                    </a:lnL>
-                    <a:lnR w="12700" cap="flat" cmpd="sng" algn="ctr">
-                      <a:solidFill>
-                        <a:srgbClr val="3A4694"/>
-                      </a:solidFill>
-                      <a:prstDash val="solid"/>
-                      <a:round/>
-                      <a:headEnd type="none" w="med" len="med"/>
-                      <a:tailEnd type="none" w="med" len="med"/>
-                    </a:lnR>
-                    <a:lnT w="12700" cap="flat" cmpd="sng" algn="ctr">
-                      <a:solidFill>
-                        <a:srgbClr val="3A4694"/>
-                      </a:solidFill>
-                      <a:prstDash val="solid"/>
-                      <a:round/>
-                      <a:headEnd type="none" w="med" len="med"/>
-                      <a:tailEnd type="none" w="med" len="med"/>
-                    </a:lnT>
-                    <a:lnB w="12700" cap="flat" cmpd="sng" algn="ctr">
-                      <a:solidFill>
-                        <a:srgbClr val="3A4694"/>
-                      </a:solidFill>
-                      <a:prstDash val="solid"/>
-                      <a:round/>
-                      <a:headEnd type="none" w="med" len="med"/>
-                      <a:tailEnd type="none" w="med" len="med"/>
-                    </a:lnB>
-                    <a:solidFill>
-                      <a:srgbClr val="141B45"/>
-                    </a:solidFill>
-                  </a:tcPr>
-                </a:tc>
-                <a:tc>
-                  <a:txBody>
-                    <a:bodyPr/>
-                    <a:lstStyle/>
-                    <a:p>
-                      <a:pPr indent="0" marL="0">
-                        <a:buNone/>
-                      </a:pPr>
-                      <a:r>
-                        <a:rPr lang="en-US" sz="1500" b="1" dirty="0">
-                          <a:solidFill>
-                            <a:srgbClr val="C9A227"/>
-                          </a:solidFill>
-                          <a:latin typeface="Calibri" pitchFamily="34" charset="0"/>
-                          <a:ea typeface="Calibri" pitchFamily="34" charset="-122"/>
-                          <a:cs typeface="Calibri" pitchFamily="34" charset="-120"/>
-                        </a:rPr>
-                        <a:t>TOTAL</a:t>
-                      </a:r>
-                      <a:endParaRPr lang="en-US" sz="1500" dirty="0">
-                        <a:latin typeface="Calibri" charset="0"/>
-                        <a:ea typeface="Calibri" charset="0"/>
-                        <a:cs typeface="Calibri" charset="0"/>
-                      </a:endParaRPr>
-                    </a:p>
-                  </a:txBody>
-                  <a:tcPr marL="91440" marR="91440" marT="45720" marB="45720" anchor="ctr">
-                    <a:lnL w="12700" cap="flat" cmpd="sng" algn="ctr">
-                      <a:solidFill>
-                        <a:srgbClr val="3A4694"/>
-                      </a:solidFill>
-                      <a:prstDash val="solid"/>
-                      <a:round/>
-                      <a:headEnd type="none" w="med" len="med"/>
-                      <a:tailEnd type="none" w="med" len="med"/>
-                    </a:lnL>
-                    <a:lnR w="12700" cap="flat" cmpd="sng" algn="ctr">
-                      <a:solidFill>
-                        <a:srgbClr val="3A4694"/>
-                      </a:solidFill>
-                      <a:prstDash val="solid"/>
-                      <a:round/>
-                      <a:headEnd type="none" w="med" len="med"/>
-                      <a:tailEnd type="none" w="med" len="med"/>
-                    </a:lnR>
-                    <a:lnT w="12700" cap="flat" cmpd="sng" algn="ctr">
-                      <a:solidFill>
-                        <a:srgbClr val="3A4694"/>
-                      </a:solidFill>
-                      <a:prstDash val="solid"/>
-                      <a:round/>
-                      <a:headEnd type="none" w="med" len="med"/>
-                      <a:tailEnd type="none" w="med" len="med"/>
-                    </a:lnT>
-                    <a:lnB w="12700" cap="flat" cmpd="sng" algn="ctr">
-                      <a:solidFill>
-                        <a:srgbClr val="3A4694"/>
-                      </a:solidFill>
-                      <a:prstDash val="solid"/>
-                      <a:round/>
-                      <a:headEnd type="none" w="med" len="med"/>
-                      <a:tailEnd type="none" w="med" len="med"/>
-                    </a:lnB>
-                    <a:solidFill>
-                      <a:srgbClr val="141B45"/>
-                    </a:solidFill>
-                  </a:tcPr>
-                </a:tc>
-                <a:tc>
-                  <a:txBody>
-                    <a:bodyPr/>
-                    <a:lstStyle/>
-                    <a:p>
-                      <a:pPr algn="ctr" indent="0" marL="0">
-                        <a:buNone/>
-                      </a:pPr>
-                      <a:r>
-                        <a:rPr lang="en-US" sz="1500" b="1" dirty="0">
-                          <a:solidFill>
-                            <a:srgbClr val="C9A227"/>
-                          </a:solidFill>
-                          <a:latin typeface="Calibri" pitchFamily="34" charset="0"/>
-                          <a:ea typeface="Calibri" pitchFamily="34" charset="-122"/>
-                          <a:cs typeface="Calibri" pitchFamily="34" charset="-120"/>
-                        </a:rPr>
-                        <a:t>30</a:t>
-                      </a:r>
-                      <a:endParaRPr lang="en-US" sz="1500" dirty="0">
-                        <a:latin typeface="Calibri" charset="0"/>
-                        <a:ea typeface="Calibri" charset="0"/>
-                        <a:cs typeface="Calibri" charset="0"/>
-                      </a:endParaRPr>
-                    </a:p>
-                  </a:txBody>
-                  <a:tcPr marL="91440" marR="91440" marT="45720" marB="45720" anchor="ctr">
-                    <a:lnL w="12700" cap="flat" cmpd="sng" algn="ctr">
-                      <a:solidFill>
-                        <a:srgbClr val="3A4694"/>
-                      </a:solidFill>
-                      <a:prstDash val="solid"/>
-                      <a:round/>
-                      <a:headEnd type="none" w="med" len="med"/>
-                      <a:tailEnd type="none" w="med" len="med"/>
-                    </a:lnL>
-                    <a:lnR w="12700" cap="flat" cmpd="sng" algn="ctr">
-                      <a:solidFill>
-                        <a:srgbClr val="3A4694"/>
-                      </a:solidFill>
-                      <a:prstDash val="solid"/>
-                      <a:round/>
-                      <a:headEnd type="none" w="med" len="med"/>
-                      <a:tailEnd type="none" w="med" len="med"/>
-                    </a:lnR>
-                    <a:lnT w="12700" cap="flat" cmpd="sng" algn="ctr">
-                      <a:solidFill>
-                        <a:srgbClr val="3A4694"/>
-                      </a:solidFill>
-                      <a:prstDash val="solid"/>
-                      <a:round/>
-                      <a:headEnd type="none" w="med" len="med"/>
-                      <a:tailEnd type="none" w="med" len="med"/>
-                    </a:lnT>
-                    <a:lnB w="12700" cap="flat" cmpd="sng" algn="ctr">
-                      <a:solidFill>
-                        <a:srgbClr val="3A4694"/>
-                      </a:solidFill>
-                      <a:prstDash val="solid"/>
-                      <a:round/>
-                      <a:headEnd type="none" w="med" len="med"/>
-                      <a:tailEnd type="none" w="med" len="med"/>
-                    </a:lnB>
-                    <a:solidFill>
-                      <a:srgbClr val="141B45"/>
-                    </a:solidFill>
-                  </a:tcPr>
-                </a:tc>
-              </a:tr>
-            </a:tbl>
-          </a:graphicData>
-        </a:graphic>
-      </p:graphicFrame>
-      <p:sp>
-        <p:nvSpPr>
-          <p:cNvPr id="7" name="Text 3"/>
+      <p:sp>
+        <p:nvSpPr>
+          <p:cNvPr id="5" name="Text 2"/>
+          <p:cNvSpPr txBox="1"/>
+          <p:nvPr/>
+        </p:nvSpPr>
+        <p:spPr>
+          <a:xfrm>
+            <a:off x="640080" y="1554480"/>
+            <a:ext cx="10881360" cy="4572000"/>
+          </a:xfrm>
+          <a:prstGeom prst="rect">
+            <a:avLst/>
+          </a:prstGeom>
+          <a:noFill/>
+          <a:ln/>
+        </p:spPr>
+        <p:txBody>
+          <a:bodyPr wrap="square" lIns="0" tIns="0" rIns="0" bIns="0" rtlCol="0" anchor="t"/>
+          <a:lstStyle/>
+          <a:p>
+            <a:pPr indent="0" marL="0">
+              <a:spcAft>
+                <a:spcPts val="1400"/>
+              </a:spcAft>
+              <a:buNone/>
+            </a:pPr>
+            <a:r>
+              <a:rPr lang="en-US" sz="1400" dirty="0">
+                <a:solidFill>
+                  <a:srgbClr val="CADCFC"/>
+                </a:solidFill>
+                <a:latin typeface="Calibri" pitchFamily="34" charset="0"/>
+                <a:ea typeface="Calibri" pitchFamily="34" charset="-122"/>
+                <a:cs typeface="Calibri" pitchFamily="34" charset="-120"/>
+              </a:rPr>
+              <a:t>1. Krawetz, “A Picture's Worth… Digital Image Analysis and Forensics,” Hacker Factor Solutions, 2007</a:t>
+            </a:r>
+            <a:endParaRPr lang="en-US" sz="1400" dirty="0"/>
+          </a:p>
+          <a:p>
+            <a:pPr indent="0" marL="0">
+              <a:spcAft>
+                <a:spcPts val="1400"/>
+              </a:spcAft>
+              <a:buNone/>
+            </a:pPr>
+            <a:r>
+              <a:rPr lang="en-US" sz="1400" dirty="0">
+                <a:solidFill>
+                  <a:srgbClr val="CADCFC"/>
+                </a:solidFill>
+                <a:latin typeface="Calibri" pitchFamily="34" charset="0"/>
+                <a:ea typeface="Calibri" pitchFamily="34" charset="-122"/>
+                <a:cs typeface="Calibri" pitchFamily="34" charset="-120"/>
+              </a:rPr>
+              <a:t>2. Chen &amp; Guestrin, “XGBoost: A Scalable Tree Boosting System,” ACM SIGKDD, 2016</a:t>
+            </a:r>
+            <a:endParaRPr lang="en-US" sz="1400" dirty="0"/>
+          </a:p>
+          <a:p>
+            <a:pPr indent="0" marL="0">
+              <a:spcAft>
+                <a:spcPts val="1400"/>
+              </a:spcAft>
+              <a:buNone/>
+            </a:pPr>
+            <a:r>
+              <a:rPr lang="en-US" sz="1400" dirty="0">
+                <a:solidFill>
+                  <a:srgbClr val="CADCFC"/>
+                </a:solidFill>
+                <a:latin typeface="Calibri" pitchFamily="34" charset="0"/>
+                <a:ea typeface="Calibri" pitchFamily="34" charset="-122"/>
+                <a:cs typeface="Calibri" pitchFamily="34" charset="-120"/>
+              </a:rPr>
+              <a:t>3. Reserve Bank of India, “Master Direction - NBFC Account Aggregator Directions,” RBI/DNBR/2016-17/45</a:t>
+            </a:r>
+            <a:endParaRPr lang="en-US" sz="1400" dirty="0"/>
+          </a:p>
+          <a:p>
+            <a:pPr indent="0" marL="0">
+              <a:spcAft>
+                <a:spcPts val="1400"/>
+              </a:spcAft>
+              <a:buNone/>
+            </a:pPr>
+            <a:r>
+              <a:rPr lang="en-US" sz="1400" dirty="0">
+                <a:solidFill>
+                  <a:srgbClr val="CADCFC"/>
+                </a:solidFill>
+                <a:latin typeface="Calibri" pitchFamily="34" charset="0"/>
+                <a:ea typeface="Calibri" pitchFamily="34" charset="-122"/>
+                <a:cs typeface="Calibri" pitchFamily="34" charset="-120"/>
+              </a:rPr>
+              <a:t>4. PyMuPDF Contributors, PyMuPDF Documentation, 2024 - pymupdf.readthedocs.io</a:t>
+            </a:r>
+            <a:endParaRPr lang="en-US" sz="1400" dirty="0"/>
+          </a:p>
+          <a:p>
+            <a:pPr indent="0" marL="0">
+              <a:spcAft>
+                <a:spcPts val="1400"/>
+              </a:spcAft>
+              <a:buNone/>
+            </a:pPr>
+            <a:r>
+              <a:rPr lang="en-US" sz="1400" dirty="0">
+                <a:solidFill>
+                  <a:srgbClr val="CADCFC"/>
+                </a:solidFill>
+                <a:latin typeface="Calibri" pitchFamily="34" charset="0"/>
+                <a:ea typeface="Calibri" pitchFamily="34" charset="-122"/>
+                <a:cs typeface="Calibri" pitchFamily="34" charset="-120"/>
+              </a:rPr>
+              <a:t>5. Smith, “An Overview of the Tesseract OCR Engine,” ICDAR, 2007</a:t>
+            </a:r>
+            <a:endParaRPr lang="en-US" sz="1400" dirty="0"/>
+          </a:p>
+          <a:p>
+            <a:pPr indent="0" marL="0">
+              <a:spcAft>
+                <a:spcPts val="1400"/>
+              </a:spcAft>
+              <a:buNone/>
+            </a:pPr>
+            <a:r>
+              <a:rPr lang="en-US" sz="1400" dirty="0">
+                <a:solidFill>
+                  <a:srgbClr val="CADCFC"/>
+                </a:solidFill>
+                <a:latin typeface="Calibri" pitchFamily="34" charset="0"/>
+                <a:ea typeface="Calibri" pitchFamily="34" charset="-122"/>
+                <a:cs typeface="Calibri" pitchFamily="34" charset="-120"/>
+              </a:rPr>
+              <a:t>6. Oracle Corp., “MySQL 8.0 Reference Manual,” 2024 - dev.mysql.com/doc/refman/8.0/en</a:t>
+            </a:r>
+            <a:endParaRPr lang="en-US" sz="1400" dirty="0"/>
+          </a:p>
+          <a:p>
+            <a:pPr indent="0" marL="0">
+              <a:spcAft>
+                <a:spcPts val="1400"/>
+              </a:spcAft>
+              <a:buNone/>
+            </a:pPr>
+            <a:r>
+              <a:rPr lang="en-US" sz="1400" dirty="0">
+                <a:solidFill>
+                  <a:srgbClr val="CADCFC"/>
+                </a:solidFill>
+                <a:latin typeface="Calibri" pitchFamily="34" charset="0"/>
+                <a:ea typeface="Calibri" pitchFamily="34" charset="-122"/>
+                <a:cs typeface="Calibri" pitchFamily="34" charset="-120"/>
+              </a:rPr>
+              <a:t>7. “Give Me Some Credit” dataset, Kaggle - kaggle.com/c/GiveMeSomeCredit</a:t>
+            </a:r>
+            <a:endParaRPr lang="en-US" sz="1400" dirty="0"/>
+          </a:p>
+          <a:p>
+            <a:pPr indent="0" marL="0">
+              <a:spcAft>
+                <a:spcPts val="1400"/>
+              </a:spcAft>
+              <a:buNone/>
+            </a:pPr>
+            <a:r>
+              <a:rPr lang="en-US" sz="1400" dirty="0">
+                <a:solidFill>
+                  <a:srgbClr val="CADCFC"/>
+                </a:solidFill>
+                <a:latin typeface="Calibri" pitchFamily="34" charset="0"/>
+                <a:ea typeface="Calibri" pitchFamily="34" charset="-122"/>
+                <a:cs typeface="Calibri" pitchFamily="34" charset="-120"/>
+              </a:rPr>
+              <a:t>8. FastAPI Documentation - fastapi.tiangolo.com</a:t>
+            </a:r>
+            <a:endParaRPr lang="en-US" sz="1400" dirty="0"/>
+          </a:p>
+          <a:p>
+            <a:pPr indent="0" marL="0">
+              <a:spcAft>
+                <a:spcPts val="1400"/>
+              </a:spcAft>
+              <a:buNone/>
+            </a:pPr>
+            <a:r>
+              <a:rPr lang="en-US" sz="1400" dirty="0">
+                <a:solidFill>
+                  <a:srgbClr val="CADCFC"/>
+                </a:solidFill>
+                <a:latin typeface="Calibri" pitchFamily="34" charset="0"/>
+                <a:ea typeface="Calibri" pitchFamily="34" charset="-122"/>
+                <a:cs typeface="Calibri" pitchFamily="34" charset="-120"/>
+              </a:rPr>
+              <a:t>9. Next.js Documentation - nextjs.org/docs</a:t>
+            </a:r>
+            <a:endParaRPr lang="en-US" sz="1400" dirty="0"/>
+          </a:p>
+        </p:txBody>
+      </p:sp>
+      <p:sp>
+        <p:nvSpPr>
+          <p:cNvPr id="6" name="Text 3"/>
           <p:cNvSpPr txBox="1"/>
           <p:nvPr/>
         </p:nvSpPr>
@@ -9089,7 +7879,7 @@
       </p:sp>
       <p:sp>
         <p:nvSpPr>
-          <p:cNvPr id="8" name="Text 4"/>
+          <p:cNvPr id="7" name="Text 4"/>
           <p:cNvSpPr txBox="1"/>
           <p:nvPr/>
         </p:nvSpPr>
@@ -9121,6 +7911,340 @@
                 <a:cs typeface="Calibri" pitchFamily="34" charset="-120"/>
               </a:rPr>
               <a:t>17</a:t>
+            </a:r>
+            <a:endParaRPr lang="en-US" sz="900" dirty="0"/>
+          </a:p>
+        </p:txBody>
+      </p:sp>
+    </p:spTree>
+  </p:cSld>
+  <p:clrMapOvr>
+    <a:masterClrMapping/>
+  </p:clrMapOvr>
+</p:sld>
+</file>
+
+<file path=ppt/slides/slide18.xml><?xml version="1.0" encoding="utf-8"?>
+<p:sld xmlns:a="http://schemas.openxmlformats.org/drawingml/2006/main" xmlns:r="http://schemas.openxmlformats.org/officeDocument/2006/relationships" xmlns:p="http://schemas.openxmlformats.org/presentationml/2006/main">
+  <p:cSld name="Slide 18">
+    <p:bg>
+      <p:bgPr>
+        <a:solidFill>
+          <a:srgbClr val="1E2761"/>
+        </a:solidFill>
+      </p:bgPr>
+    </p:bg>
+    <p:spTree>
+      <p:nvGrpSpPr>
+        <p:cNvPr id="1" name=""/>
+        <p:cNvGrpSpPr/>
+        <p:nvPr/>
+      </p:nvGrpSpPr>
+      <p:grpSpPr>
+        <a:xfrm>
+          <a:off x="0" y="0"/>
+          <a:ext cx="0" cy="0"/>
+          <a:chOff x="0" y="0"/>
+          <a:chExt cx="0" cy="0"/>
+        </a:xfrm>
+      </p:grpSpPr>
+      <p:sp>
+        <p:nvSpPr>
+          <p:cNvPr id="2" name="Shape 0"/>
+          <p:cNvSpPr/>
+          <p:nvPr/>
+        </p:nvSpPr>
+        <p:spPr>
+          <a:xfrm>
+            <a:off x="9692640" y="-1280160"/>
+            <a:ext cx="4114800" cy="4114800"/>
+          </a:xfrm>
+          <a:prstGeom prst="ellipse">
+            <a:avLst/>
+          </a:prstGeom>
+          <a:solidFill>
+            <a:srgbClr val="141B45"/>
+          </a:solidFill>
+          <a:ln/>
+        </p:spPr>
+      </p:sp>
+      <p:sp>
+        <p:nvSpPr>
+          <p:cNvPr id="3" name="Shape 1"/>
+          <p:cNvSpPr/>
+          <p:nvPr/>
+        </p:nvSpPr>
+        <p:spPr>
+          <a:xfrm>
+            <a:off x="-1463040" y="5120640"/>
+            <a:ext cx="3291840" cy="3291840"/>
+          </a:xfrm>
+          <a:prstGeom prst="ellipse">
+            <a:avLst/>
+          </a:prstGeom>
+          <a:solidFill>
+            <a:srgbClr val="141B45"/>
+          </a:solidFill>
+          <a:ln/>
+        </p:spPr>
+      </p:sp>
+      <p:sp>
+        <p:nvSpPr>
+          <p:cNvPr id="4" name="Shape 2"/>
+          <p:cNvSpPr/>
+          <p:nvPr/>
+        </p:nvSpPr>
+        <p:spPr>
+          <a:xfrm>
+            <a:off x="5632704" y="1371600"/>
+            <a:ext cx="914400" cy="914400"/>
+          </a:xfrm>
+          <a:prstGeom prst="ellipse">
+            <a:avLst/>
+          </a:prstGeom>
+          <a:solidFill>
+            <a:srgbClr val="C9A227"/>
+          </a:solidFill>
+          <a:ln/>
+        </p:spPr>
+      </p:sp>
+      <p:pic>
+        <p:nvPicPr>
+          <p:cNvPr id="5" name="Image 0" descr="preencoded.png">    </p:cNvPr>
+          <p:cNvPicPr>
+            <a:picLocks noChangeAspect="1"/>
+          </p:cNvPicPr>
+          <p:nvPr/>
+        </p:nvPicPr>
+        <p:blipFill>
+          <a:blip r:embed="rId1"/>
+          <a:stretch>
+            <a:fillRect/>
+          </a:stretch>
+        </p:blipFill>
+        <p:spPr>
+          <a:xfrm>
+            <a:off x="5742432" y="1481328"/>
+            <a:ext cx="694944" cy="694944"/>
+          </a:xfrm>
+          <a:prstGeom prst="rect">
+            <a:avLst/>
+          </a:prstGeom>
+        </p:spPr>
+      </p:pic>
+      <p:sp>
+        <p:nvSpPr>
+          <p:cNvPr id="6" name="Text 3"/>
+          <p:cNvSpPr txBox="1"/>
+          <p:nvPr/>
+        </p:nvSpPr>
+        <p:spPr>
+          <a:xfrm>
+            <a:off x="914400" y="2514600"/>
+            <a:ext cx="10360152" cy="1005840"/>
+          </a:xfrm>
+          <a:prstGeom prst="rect">
+            <a:avLst/>
+          </a:prstGeom>
+          <a:noFill/>
+          <a:ln/>
+        </p:spPr>
+        <p:txBody>
+          <a:bodyPr wrap="square" lIns="0" tIns="0" rIns="0" bIns="0" rtlCol="0" anchor="ctr"/>
+          <a:lstStyle/>
+          <a:p>
+            <a:pPr algn="ctr" indent="0" marL="0">
+              <a:buNone/>
+            </a:pPr>
+            <a:r>
+              <a:rPr lang="en-US" sz="4400" b="1" dirty="0">
+                <a:solidFill>
+                  <a:srgbClr val="FFFFFF"/>
+                </a:solidFill>
+                <a:latin typeface="Cambria" pitchFamily="34" charset="0"/>
+                <a:ea typeface="Cambria" pitchFamily="34" charset="-122"/>
+                <a:cs typeface="Cambria" pitchFamily="34" charset="-120"/>
+              </a:rPr>
+              <a:t>Thank You</a:t>
+            </a:r>
+            <a:endParaRPr lang="en-US" sz="4400" dirty="0"/>
+          </a:p>
+        </p:txBody>
+      </p:sp>
+      <p:sp>
+        <p:nvSpPr>
+          <p:cNvPr id="7" name="Text 4"/>
+          <p:cNvSpPr txBox="1"/>
+          <p:nvPr/>
+        </p:nvSpPr>
+        <p:spPr>
+          <a:xfrm>
+            <a:off x="914400" y="3520440"/>
+            <a:ext cx="10360152" cy="502920"/>
+          </a:xfrm>
+          <a:prstGeom prst="rect">
+            <a:avLst/>
+          </a:prstGeom>
+          <a:noFill/>
+          <a:ln/>
+        </p:spPr>
+        <p:txBody>
+          <a:bodyPr wrap="square" lIns="0" tIns="0" rIns="0" bIns="0" rtlCol="0" anchor="ctr"/>
+          <a:lstStyle/>
+          <a:p>
+            <a:pPr algn="ctr" indent="0" marL="0">
+              <a:buNone/>
+            </a:pPr>
+            <a:r>
+              <a:rPr lang="en-US" sz="1800" i="1" dirty="0">
+                <a:solidFill>
+                  <a:srgbClr val="CADCFC"/>
+                </a:solidFill>
+                <a:latin typeface="Calibri" pitchFamily="34" charset="0"/>
+                <a:ea typeface="Calibri" pitchFamily="34" charset="-122"/>
+                <a:cs typeface="Calibri" pitchFamily="34" charset="-120"/>
+              </a:rPr>
+              <a:t>Questions &amp; Discussion</a:t>
+            </a:r>
+            <a:endParaRPr lang="en-US" sz="1800" dirty="0"/>
+          </a:p>
+        </p:txBody>
+      </p:sp>
+      <p:sp>
+        <p:nvSpPr>
+          <p:cNvPr id="8" name="Shape 5"/>
+          <p:cNvSpPr/>
+          <p:nvPr/>
+        </p:nvSpPr>
+        <p:spPr>
+          <a:xfrm>
+            <a:off x="4718304" y="4343400"/>
+            <a:ext cx="2743200" cy="0"/>
+          </a:xfrm>
+          <a:prstGeom prst="line">
+            <a:avLst/>
+          </a:prstGeom>
+          <a:noFill/>
+          <a:ln w="12700">
+            <a:solidFill>
+              <a:srgbClr val="3A4694"/>
+            </a:solidFill>
+            <a:prstDash val="solid"/>
+          </a:ln>
+        </p:spPr>
+      </p:sp>
+      <p:sp>
+        <p:nvSpPr>
+          <p:cNvPr id="9" name="Text 6"/>
+          <p:cNvSpPr txBox="1"/>
+          <p:nvPr/>
+        </p:nvSpPr>
+        <p:spPr>
+          <a:xfrm>
+            <a:off x="914400" y="4526280"/>
+            <a:ext cx="10360152" cy="365760"/>
+          </a:xfrm>
+          <a:prstGeom prst="rect">
+            <a:avLst/>
+          </a:prstGeom>
+          <a:noFill/>
+          <a:ln/>
+        </p:spPr>
+        <p:txBody>
+          <a:bodyPr wrap="square" lIns="0" tIns="0" rIns="0" bIns="0" rtlCol="0" anchor="ctr"/>
+          <a:lstStyle/>
+          <a:p>
+            <a:pPr algn="ctr" indent="0" marL="0">
+              <a:buNone/>
+            </a:pPr>
+            <a:r>
+              <a:rPr lang="en-US" sz="1400" dirty="0">
+                <a:solidFill>
+                  <a:srgbClr val="CADCFC"/>
+                </a:solidFill>
+                <a:latin typeface="Calibri" pitchFamily="34" charset="0"/>
+                <a:ea typeface="Calibri" pitchFamily="34" charset="-122"/>
+                <a:cs typeface="Calibri" pitchFamily="34" charset="-120"/>
+              </a:rPr>
+              <a:t>Naresh S  |  Roll No: 2436MCA0047</a:t>
+            </a:r>
+            <a:endParaRPr lang="en-US" sz="1400" dirty="0"/>
+          </a:p>
+        </p:txBody>
+      </p:sp>
+      <p:sp>
+        <p:nvSpPr>
+          <p:cNvPr id="10" name="Text 7"/>
+          <p:cNvSpPr txBox="1"/>
+          <p:nvPr/>
+        </p:nvSpPr>
+        <p:spPr>
+          <a:xfrm>
+            <a:off x="457200" y="6510528"/>
+            <a:ext cx="9601200" cy="274320"/>
+          </a:xfrm>
+          <a:prstGeom prst="rect">
+            <a:avLst/>
+          </a:prstGeom>
+          <a:noFill/>
+          <a:ln/>
+        </p:spPr>
+        <p:txBody>
+          <a:bodyPr wrap="square" lIns="0" tIns="0" rIns="0" bIns="0" rtlCol="0" anchor="ctr"/>
+          <a:lstStyle/>
+          <a:p>
+            <a:pPr indent="0" marL="0">
+              <a:buNone/>
+            </a:pPr>
+            <a:r>
+              <a:rPr lang="en-US" sz="900" dirty="0">
+                <a:solidFill>
+                  <a:srgbClr val="8A95C4"/>
+                </a:solidFill>
+                <a:latin typeface="Calibri" pitchFamily="34" charset="0"/>
+                <a:ea typeface="Calibri" pitchFamily="34" charset="-122"/>
+                <a:cs typeface="Calibri" pitchFamily="34" charset="-120"/>
+              </a:rPr>
+              <a:t>First Review – Automated AI-Driven Loan Underwriting &amp; Document Fraud Detection</a:t>
+            </a:r>
+            <a:endParaRPr lang="en-US" sz="900" dirty="0"/>
+          </a:p>
+        </p:txBody>
+      </p:sp>
+      <p:sp>
+        <p:nvSpPr>
+          <p:cNvPr id="11" name="Text 8"/>
+          <p:cNvSpPr txBox="1"/>
+          <p:nvPr/>
+        </p:nvSpPr>
+        <p:spPr>
+          <a:xfrm>
+            <a:off x="11430000" y="6510528"/>
+            <a:ext cx="365760" cy="274320"/>
+          </a:xfrm>
+          <a:prstGeom prst="rect">
+            <a:avLst/>
+          </a:prstGeom>
+          <a:noFill/>
+          <a:ln/>
+        </p:spPr>
+        <p:txBody>
+          <a:bodyPr wrap="square" lIns="0" tIns="0" rIns="0" bIns="0" rtlCol="0" anchor="ctr"/>
+          <a:lstStyle/>
+          <a:p>
+            <a:pPr algn="r" indent="0" marL="0">
+              <a:buNone/>
+            </a:pPr>
+            <a:r>
+              <a:rPr lang="en-US" sz="900" dirty="0">
+                <a:solidFill>
+                  <a:srgbClr val="8A95C4"/>
+                </a:solidFill>
+                <a:latin typeface="Calibri" pitchFamily="34" charset="0"/>
+                <a:ea typeface="Calibri" pitchFamily="34" charset="-122"/>
+                <a:cs typeface="Calibri" pitchFamily="34" charset="-120"/>
+              </a:rPr>
+              <a:t>18</a:t>
             </a:r>
             <a:endParaRPr lang="en-US" sz="900" dirty="0"/>
           </a:p>
@@ -9283,67 +8407,6 @@
         </p:nvSpPr>
         <p:spPr>
           <a:xfrm>
-            <a:off x="9537192" y="384048"/>
-            <a:ext cx="1737360" cy="411480"/>
-          </a:xfrm>
-          <a:prstGeom prst="roundRect">
-            <a:avLst>
-              <a:gd name="adj" fmla="val 17778"/>
-            </a:avLst>
-          </a:prstGeom>
-          <a:solidFill>
-            <a:srgbClr val="C9A227"/>
-          </a:solidFill>
-          <a:ln/>
-        </p:spPr>
-      </p:sp>
-      <p:sp>
-        <p:nvSpPr>
-          <p:cNvPr id="6" name="Text 4"/>
-          <p:cNvSpPr txBox="1"/>
-          <p:nvPr/>
-        </p:nvSpPr>
-        <p:spPr>
-          <a:xfrm>
-            <a:off x="9537192" y="384048"/>
-            <a:ext cx="1737360" cy="411480"/>
-          </a:xfrm>
-          <a:prstGeom prst="rect">
-            <a:avLst/>
-          </a:prstGeom>
-          <a:noFill/>
-          <a:ln/>
-        </p:spPr>
-        <p:txBody>
-          <a:bodyPr wrap="square" lIns="0" tIns="0" rIns="0" bIns="0" rtlCol="0" anchor="ctr"/>
-          <a:lstStyle/>
-          <a:p>
-            <a:pPr algn="ctr" indent="0" marL="0">
-              <a:buNone/>
-            </a:pPr>
-            <a:r>
-              <a:rPr lang="en-US" sz="1300" b="1" spc="50" kern="0" dirty="0">
-                <a:solidFill>
-                  <a:srgbClr val="141B45"/>
-                </a:solidFill>
-                <a:latin typeface="Calibri" pitchFamily="34" charset="0"/>
-                <a:ea typeface="Calibri" pitchFamily="34" charset="-122"/>
-                <a:cs typeface="Calibri" pitchFamily="34" charset="-120"/>
-              </a:rPr>
-              <a:t>4 MARKS</a:t>
-            </a:r>
-            <a:endParaRPr lang="en-US" sz="1300" dirty="0"/>
-          </a:p>
-        </p:txBody>
-      </p:sp>
-      <p:sp>
-        <p:nvSpPr>
-          <p:cNvPr id="7" name="Shape 5"/>
-          <p:cNvSpPr/>
-          <p:nvPr/>
-        </p:nvSpPr>
-        <p:spPr>
-          <a:xfrm>
             <a:off x="548640" y="1737360"/>
             <a:ext cx="3566160" cy="2331720"/>
           </a:xfrm>
@@ -9367,7 +8430,7 @@
       </p:sp>
       <p:sp>
         <p:nvSpPr>
-          <p:cNvPr id="8" name="Shape 6"/>
+          <p:cNvPr id="6" name="Shape 4"/>
           <p:cNvSpPr/>
           <p:nvPr/>
         </p:nvSpPr>
@@ -9387,7 +8450,7 @@
       </p:sp>
       <p:pic>
         <p:nvPicPr>
-          <p:cNvPr id="9" name="Image 0" descr="preencoded.png">    </p:cNvPr>
+          <p:cNvPr id="7" name="Image 0" descr="preencoded.png">    </p:cNvPr>
           <p:cNvPicPr>
             <a:picLocks noChangeAspect="1"/>
           </p:cNvPicPr>
@@ -9411,7 +8474,7 @@
       </p:pic>
       <p:sp>
         <p:nvSpPr>
-          <p:cNvPr id="10" name="Text 7"/>
+          <p:cNvPr id="8" name="Text 5"/>
           <p:cNvSpPr txBox="1"/>
           <p:nvPr/>
         </p:nvSpPr>
@@ -9450,7 +8513,7 @@
       </p:sp>
       <p:sp>
         <p:nvSpPr>
-          <p:cNvPr id="11" name="Text 8"/>
+          <p:cNvPr id="9" name="Text 6"/>
           <p:cNvSpPr txBox="1"/>
           <p:nvPr/>
         </p:nvSpPr>
@@ -9489,7 +8552,7 @@
       </p:sp>
       <p:sp>
         <p:nvSpPr>
-          <p:cNvPr id="12" name="Shape 9"/>
+          <p:cNvPr id="10" name="Shape 7"/>
           <p:cNvSpPr/>
           <p:nvPr/>
         </p:nvSpPr>
@@ -9518,7 +8581,7 @@
       </p:sp>
       <p:sp>
         <p:nvSpPr>
-          <p:cNvPr id="13" name="Shape 10"/>
+          <p:cNvPr id="11" name="Shape 8"/>
           <p:cNvSpPr/>
           <p:nvPr/>
         </p:nvSpPr>
@@ -9538,7 +8601,7 @@
       </p:sp>
       <p:pic>
         <p:nvPicPr>
-          <p:cNvPr id="14" name="Image 1" descr="preencoded.png">    </p:cNvPr>
+          <p:cNvPr id="12" name="Image 1" descr="preencoded.png">    </p:cNvPr>
           <p:cNvPicPr>
             <a:picLocks noChangeAspect="1"/>
           </p:cNvPicPr>
@@ -9562,7 +8625,7 @@
       </p:pic>
       <p:sp>
         <p:nvSpPr>
-          <p:cNvPr id="15" name="Text 11"/>
+          <p:cNvPr id="13" name="Text 9"/>
           <p:cNvSpPr txBox="1"/>
           <p:nvPr/>
         </p:nvSpPr>
@@ -9601,7 +8664,7 @@
       </p:sp>
       <p:sp>
         <p:nvSpPr>
-          <p:cNvPr id="16" name="Text 12"/>
+          <p:cNvPr id="14" name="Text 10"/>
           <p:cNvSpPr txBox="1"/>
           <p:nvPr/>
         </p:nvSpPr>
@@ -9640,7 +8703,7 @@
       </p:sp>
       <p:sp>
         <p:nvSpPr>
-          <p:cNvPr id="17" name="Shape 13"/>
+          <p:cNvPr id="15" name="Shape 11"/>
           <p:cNvSpPr/>
           <p:nvPr/>
         </p:nvSpPr>
@@ -9669,7 +8732,7 @@
       </p:sp>
       <p:sp>
         <p:nvSpPr>
-          <p:cNvPr id="18" name="Shape 14"/>
+          <p:cNvPr id="16" name="Shape 12"/>
           <p:cNvSpPr/>
           <p:nvPr/>
         </p:nvSpPr>
@@ -9689,7 +8752,7 @@
       </p:sp>
       <p:pic>
         <p:nvPicPr>
-          <p:cNvPr id="19" name="Image 2" descr="preencoded.png">    </p:cNvPr>
+          <p:cNvPr id="17" name="Image 2" descr="preencoded.png">    </p:cNvPr>
           <p:cNvPicPr>
             <a:picLocks noChangeAspect="1"/>
           </p:cNvPicPr>
@@ -9713,7 +8776,7 @@
       </p:pic>
       <p:sp>
         <p:nvSpPr>
-          <p:cNvPr id="20" name="Text 15"/>
+          <p:cNvPr id="18" name="Text 13"/>
           <p:cNvSpPr txBox="1"/>
           <p:nvPr/>
         </p:nvSpPr>
@@ -9752,7 +8815,7 @@
       </p:sp>
       <p:sp>
         <p:nvSpPr>
-          <p:cNvPr id="21" name="Text 16"/>
+          <p:cNvPr id="19" name="Text 14"/>
           <p:cNvSpPr txBox="1"/>
           <p:nvPr/>
         </p:nvSpPr>
@@ -9791,7 +8854,7 @@
       </p:sp>
       <p:sp>
         <p:nvSpPr>
-          <p:cNvPr id="22" name="Shape 17"/>
+          <p:cNvPr id="20" name="Shape 15"/>
           <p:cNvSpPr/>
           <p:nvPr/>
         </p:nvSpPr>
@@ -9813,7 +8876,7 @@
       </p:sp>
       <p:sp>
         <p:nvSpPr>
-          <p:cNvPr id="23" name="Text 18"/>
+          <p:cNvPr id="21" name="Text 16"/>
           <p:cNvSpPr txBox="1"/>
           <p:nvPr/>
         </p:nvSpPr>
@@ -9852,7 +8915,7 @@
       </p:sp>
       <p:sp>
         <p:nvSpPr>
-          <p:cNvPr id="24" name="Text 19"/>
+          <p:cNvPr id="22" name="Text 17"/>
           <p:cNvSpPr txBox="1"/>
           <p:nvPr/>
         </p:nvSpPr>
@@ -9894,7 +8957,7 @@
       </p:sp>
       <p:sp>
         <p:nvSpPr>
-          <p:cNvPr id="25" name="Text 20"/>
+          <p:cNvPr id="23" name="Text 18"/>
           <p:cNvSpPr txBox="1"/>
           <p:nvPr/>
         </p:nvSpPr>
@@ -9933,7 +8996,7 @@
       </p:sp>
       <p:sp>
         <p:nvSpPr>
-          <p:cNvPr id="26" name="Text 21"/>
+          <p:cNvPr id="24" name="Text 19"/>
           <p:cNvSpPr txBox="1"/>
           <p:nvPr/>
         </p:nvSpPr>
@@ -10127,13 +9190,11 @@
         </p:nvSpPr>
         <p:spPr>
           <a:xfrm>
-            <a:off x="9537192" y="384048"/>
-            <a:ext cx="1737360" cy="411480"/>
-          </a:xfrm>
-          <a:prstGeom prst="roundRect">
-            <a:avLst>
-              <a:gd name="adj" fmla="val 17778"/>
-            </a:avLst>
+            <a:off x="548640" y="1737360"/>
+            <a:ext cx="502920" cy="502920"/>
+          </a:xfrm>
+          <a:prstGeom prst="ellipse">
+            <a:avLst/>
           </a:prstGeom>
           <a:solidFill>
             <a:srgbClr val="C9A227"/>
@@ -10149,65 +9210,6 @@
         </p:nvSpPr>
         <p:spPr>
           <a:xfrm>
-            <a:off x="9537192" y="384048"/>
-            <a:ext cx="1737360" cy="411480"/>
-          </a:xfrm>
-          <a:prstGeom prst="rect">
-            <a:avLst/>
-          </a:prstGeom>
-          <a:noFill/>
-          <a:ln/>
-        </p:spPr>
-        <p:txBody>
-          <a:bodyPr wrap="square" lIns="0" tIns="0" rIns="0" bIns="0" rtlCol="0" anchor="ctr"/>
-          <a:lstStyle/>
-          <a:p>
-            <a:pPr algn="ctr" indent="0" marL="0">
-              <a:buNone/>
-            </a:pPr>
-            <a:r>
-              <a:rPr lang="en-US" sz="1300" b="1" spc="50" kern="0" dirty="0">
-                <a:solidFill>
-                  <a:srgbClr val="141B45"/>
-                </a:solidFill>
-                <a:latin typeface="Calibri" pitchFamily="34" charset="0"/>
-                <a:ea typeface="Calibri" pitchFamily="34" charset="-122"/>
-                <a:cs typeface="Calibri" pitchFamily="34" charset="-120"/>
-              </a:rPr>
-              <a:t>6 MARKS</a:t>
-            </a:r>
-            <a:endParaRPr lang="en-US" sz="1300" dirty="0"/>
-          </a:p>
-        </p:txBody>
-      </p:sp>
-      <p:sp>
-        <p:nvSpPr>
-          <p:cNvPr id="7" name="Shape 5"/>
-          <p:cNvSpPr/>
-          <p:nvPr/>
-        </p:nvSpPr>
-        <p:spPr>
-          <a:xfrm>
-            <a:off x="548640" y="1737360"/>
-            <a:ext cx="502920" cy="502920"/>
-          </a:xfrm>
-          <a:prstGeom prst="ellipse">
-            <a:avLst/>
-          </a:prstGeom>
-          <a:solidFill>
-            <a:srgbClr val="C9A227"/>
-          </a:solidFill>
-          <a:ln/>
-        </p:spPr>
-      </p:sp>
-      <p:sp>
-        <p:nvSpPr>
-          <p:cNvPr id="8" name="Text 6"/>
-          <p:cNvSpPr txBox="1"/>
-          <p:nvPr/>
-        </p:nvSpPr>
-        <p:spPr>
-          <a:xfrm>
             <a:off x="548640" y="1737360"/>
             <a:ext cx="502920" cy="502920"/>
           </a:xfrm>
@@ -10241,7 +9243,7 @@
       </p:sp>
       <p:sp>
         <p:nvSpPr>
-          <p:cNvPr id="9" name="Text 7"/>
+          <p:cNvPr id="7" name="Text 5"/>
           <p:cNvSpPr txBox="1"/>
           <p:nvPr/>
         </p:nvSpPr>
@@ -10280,7 +9282,7 @@
       </p:sp>
       <p:sp>
         <p:nvSpPr>
-          <p:cNvPr id="10" name="Text 8"/>
+          <p:cNvPr id="8" name="Text 6"/>
           <p:cNvSpPr txBox="1"/>
           <p:nvPr/>
         </p:nvSpPr>
@@ -10319,7 +9321,7 @@
       </p:sp>
       <p:sp>
         <p:nvSpPr>
-          <p:cNvPr id="11" name="Shape 9"/>
+          <p:cNvPr id="9" name="Shape 7"/>
           <p:cNvSpPr/>
           <p:nvPr/>
         </p:nvSpPr>
@@ -10342,7 +9344,7 @@
       </p:sp>
       <p:sp>
         <p:nvSpPr>
-          <p:cNvPr id="12" name="Shape 10"/>
+          <p:cNvPr id="10" name="Shape 8"/>
           <p:cNvSpPr/>
           <p:nvPr/>
         </p:nvSpPr>
@@ -10362,7 +9364,7 @@
       </p:sp>
       <p:sp>
         <p:nvSpPr>
-          <p:cNvPr id="13" name="Text 11"/>
+          <p:cNvPr id="11" name="Text 9"/>
           <p:cNvSpPr txBox="1"/>
           <p:nvPr/>
         </p:nvSpPr>
@@ -10401,7 +9403,7 @@
       </p:sp>
       <p:sp>
         <p:nvSpPr>
-          <p:cNvPr id="14" name="Text 12"/>
+          <p:cNvPr id="12" name="Text 10"/>
           <p:cNvSpPr txBox="1"/>
           <p:nvPr/>
         </p:nvSpPr>
@@ -10440,7 +9442,7 @@
       </p:sp>
       <p:sp>
         <p:nvSpPr>
-          <p:cNvPr id="15" name="Text 13"/>
+          <p:cNvPr id="13" name="Text 11"/>
           <p:cNvSpPr txBox="1"/>
           <p:nvPr/>
         </p:nvSpPr>
@@ -10479,7 +9481,7 @@
       </p:sp>
       <p:sp>
         <p:nvSpPr>
-          <p:cNvPr id="16" name="Shape 14"/>
+          <p:cNvPr id="14" name="Shape 12"/>
           <p:cNvSpPr/>
           <p:nvPr/>
         </p:nvSpPr>
@@ -10502,7 +9504,7 @@
       </p:sp>
       <p:sp>
         <p:nvSpPr>
-          <p:cNvPr id="17" name="Shape 15"/>
+          <p:cNvPr id="15" name="Shape 13"/>
           <p:cNvSpPr/>
           <p:nvPr/>
         </p:nvSpPr>
@@ -10522,7 +9524,7 @@
       </p:sp>
       <p:sp>
         <p:nvSpPr>
-          <p:cNvPr id="18" name="Text 16"/>
+          <p:cNvPr id="16" name="Text 14"/>
           <p:cNvSpPr txBox="1"/>
           <p:nvPr/>
         </p:nvSpPr>
@@ -10561,7 +9563,7 @@
       </p:sp>
       <p:sp>
         <p:nvSpPr>
-          <p:cNvPr id="19" name="Text 17"/>
+          <p:cNvPr id="17" name="Text 15"/>
           <p:cNvSpPr txBox="1"/>
           <p:nvPr/>
         </p:nvSpPr>
@@ -10600,7 +9602,7 @@
       </p:sp>
       <p:sp>
         <p:nvSpPr>
-          <p:cNvPr id="20" name="Text 18"/>
+          <p:cNvPr id="18" name="Text 16"/>
           <p:cNvSpPr txBox="1"/>
           <p:nvPr/>
         </p:nvSpPr>
@@ -10639,7 +9641,7 @@
       </p:sp>
       <p:sp>
         <p:nvSpPr>
-          <p:cNvPr id="21" name="Shape 19"/>
+          <p:cNvPr id="19" name="Shape 17"/>
           <p:cNvSpPr/>
           <p:nvPr/>
         </p:nvSpPr>
@@ -10662,7 +9664,7 @@
       </p:sp>
       <p:sp>
         <p:nvSpPr>
-          <p:cNvPr id="22" name="Shape 20"/>
+          <p:cNvPr id="20" name="Shape 18"/>
           <p:cNvSpPr/>
           <p:nvPr/>
         </p:nvSpPr>
@@ -10682,7 +9684,7 @@
       </p:sp>
       <p:sp>
         <p:nvSpPr>
-          <p:cNvPr id="23" name="Text 21"/>
+          <p:cNvPr id="21" name="Text 19"/>
           <p:cNvSpPr txBox="1"/>
           <p:nvPr/>
         </p:nvSpPr>
@@ -10721,7 +9723,7 @@
       </p:sp>
       <p:sp>
         <p:nvSpPr>
-          <p:cNvPr id="24" name="Text 22"/>
+          <p:cNvPr id="22" name="Text 20"/>
           <p:cNvSpPr txBox="1"/>
           <p:nvPr/>
         </p:nvSpPr>
@@ -10760,7 +9762,7 @@
       </p:sp>
       <p:sp>
         <p:nvSpPr>
-          <p:cNvPr id="25" name="Text 23"/>
+          <p:cNvPr id="23" name="Text 21"/>
           <p:cNvSpPr txBox="1"/>
           <p:nvPr/>
         </p:nvSpPr>
@@ -10799,7 +9801,7 @@
       </p:sp>
       <p:sp>
         <p:nvSpPr>
-          <p:cNvPr id="26" name="Shape 24"/>
+          <p:cNvPr id="24" name="Shape 22"/>
           <p:cNvSpPr/>
           <p:nvPr/>
         </p:nvSpPr>
@@ -10822,7 +9824,7 @@
       </p:sp>
       <p:sp>
         <p:nvSpPr>
-          <p:cNvPr id="27" name="Shape 25"/>
+          <p:cNvPr id="25" name="Shape 23"/>
           <p:cNvSpPr/>
           <p:nvPr/>
         </p:nvSpPr>
@@ -10842,7 +9844,7 @@
       </p:sp>
       <p:sp>
         <p:nvSpPr>
-          <p:cNvPr id="28" name="Text 26"/>
+          <p:cNvPr id="26" name="Text 24"/>
           <p:cNvSpPr txBox="1"/>
           <p:nvPr/>
         </p:nvSpPr>
@@ -10881,7 +9883,7 @@
       </p:sp>
       <p:sp>
         <p:nvSpPr>
-          <p:cNvPr id="29" name="Text 27"/>
+          <p:cNvPr id="27" name="Text 25"/>
           <p:cNvSpPr txBox="1"/>
           <p:nvPr/>
         </p:nvSpPr>
@@ -10920,7 +9922,7 @@
       </p:sp>
       <p:sp>
         <p:nvSpPr>
-          <p:cNvPr id="30" name="Text 28"/>
+          <p:cNvPr id="28" name="Text 26"/>
           <p:cNvSpPr txBox="1"/>
           <p:nvPr/>
         </p:nvSpPr>
@@ -10959,7 +9961,7 @@
       </p:sp>
       <p:sp>
         <p:nvSpPr>
-          <p:cNvPr id="31" name="Text 29"/>
+          <p:cNvPr id="29" name="Text 27"/>
           <p:cNvSpPr txBox="1"/>
           <p:nvPr/>
         </p:nvSpPr>
@@ -10998,7 +10000,7 @@
       </p:sp>
       <p:sp>
         <p:nvSpPr>
-          <p:cNvPr id="32" name="Text 30"/>
+          <p:cNvPr id="30" name="Text 28"/>
           <p:cNvSpPr txBox="1"/>
           <p:nvPr/>
         </p:nvSpPr>
@@ -11192,67 +10194,6 @@
         </p:nvSpPr>
         <p:spPr>
           <a:xfrm>
-            <a:off x="9537192" y="384048"/>
-            <a:ext cx="1737360" cy="411480"/>
-          </a:xfrm>
-          <a:prstGeom prst="roundRect">
-            <a:avLst>
-              <a:gd name="adj" fmla="val 17778"/>
-            </a:avLst>
-          </a:prstGeom>
-          <a:solidFill>
-            <a:srgbClr val="C9A227"/>
-          </a:solidFill>
-          <a:ln/>
-        </p:spPr>
-      </p:sp>
-      <p:sp>
-        <p:nvSpPr>
-          <p:cNvPr id="6" name="Text 4"/>
-          <p:cNvSpPr txBox="1"/>
-          <p:nvPr/>
-        </p:nvSpPr>
-        <p:spPr>
-          <a:xfrm>
-            <a:off x="9537192" y="384048"/>
-            <a:ext cx="1737360" cy="411480"/>
-          </a:xfrm>
-          <a:prstGeom prst="rect">
-            <a:avLst/>
-          </a:prstGeom>
-          <a:noFill/>
-          <a:ln/>
-        </p:spPr>
-        <p:txBody>
-          <a:bodyPr wrap="square" lIns="0" tIns="0" rIns="0" bIns="0" rtlCol="0" anchor="ctr"/>
-          <a:lstStyle/>
-          <a:p>
-            <a:pPr algn="ctr" indent="0" marL="0">
-              <a:buNone/>
-            </a:pPr>
-            <a:r>
-              <a:rPr lang="en-US" sz="1300" b="1" spc="50" kern="0" dirty="0">
-                <a:solidFill>
-                  <a:srgbClr val="141B45"/>
-                </a:solidFill>
-                <a:latin typeface="Calibri" pitchFamily="34" charset="0"/>
-                <a:ea typeface="Calibri" pitchFamily="34" charset="-122"/>
-                <a:cs typeface="Calibri" pitchFamily="34" charset="-120"/>
-              </a:rPr>
-              <a:t>6 MARKS</a:t>
-            </a:r>
-            <a:endParaRPr lang="en-US" sz="1300" dirty="0"/>
-          </a:p>
-        </p:txBody>
-      </p:sp>
-      <p:sp>
-        <p:nvSpPr>
-          <p:cNvPr id="7" name="Shape 5"/>
-          <p:cNvSpPr/>
-          <p:nvPr/>
-        </p:nvSpPr>
-        <p:spPr>
-          <a:xfrm>
             <a:off x="548640" y="1691640"/>
             <a:ext cx="5349240" cy="3611880"/>
           </a:xfrm>
@@ -11269,7 +10210,7 @@
       </p:sp>
       <p:sp>
         <p:nvSpPr>
-          <p:cNvPr id="8" name="Shape 6"/>
+          <p:cNvPr id="6" name="Shape 4"/>
           <p:cNvSpPr/>
           <p:nvPr/>
         </p:nvSpPr>
@@ -11289,7 +10230,7 @@
       </p:sp>
       <p:pic>
         <p:nvPicPr>
-          <p:cNvPr id="9" name="Image 0" descr="preencoded.png">    </p:cNvPr>
+          <p:cNvPr id="7" name="Image 0" descr="preencoded.png">    </p:cNvPr>
           <p:cNvPicPr>
             <a:picLocks noChangeAspect="1"/>
           </p:cNvPicPr>
@@ -11313,7 +10254,7 @@
       </p:pic>
       <p:sp>
         <p:nvSpPr>
-          <p:cNvPr id="10" name="Text 7"/>
+          <p:cNvPr id="8" name="Text 5"/>
           <p:cNvSpPr txBox="1"/>
           <p:nvPr/>
         </p:nvSpPr>
@@ -11352,7 +10293,7 @@
       </p:sp>
       <p:sp>
         <p:nvSpPr>
-          <p:cNvPr id="11" name="Text 8"/>
+          <p:cNvPr id="9" name="Text 6"/>
           <p:cNvSpPr txBox="1"/>
           <p:nvPr/>
         </p:nvSpPr>
@@ -11458,7 +10399,7 @@
       </p:sp>
       <p:sp>
         <p:nvSpPr>
-          <p:cNvPr id="12" name="Shape 9"/>
+          <p:cNvPr id="10" name="Shape 7"/>
           <p:cNvSpPr/>
           <p:nvPr/>
         </p:nvSpPr>
@@ -11480,7 +10421,7 @@
       </p:sp>
       <p:sp>
         <p:nvSpPr>
-          <p:cNvPr id="13" name="Shape 10"/>
+          <p:cNvPr id="11" name="Shape 8"/>
           <p:cNvSpPr/>
           <p:nvPr/>
         </p:nvSpPr>
@@ -11500,7 +10441,7 @@
       </p:sp>
       <p:pic>
         <p:nvPicPr>
-          <p:cNvPr id="14" name="Image 1" descr="preencoded.png">    </p:cNvPr>
+          <p:cNvPr id="12" name="Image 1" descr="preencoded.png">    </p:cNvPr>
           <p:cNvPicPr>
             <a:picLocks noChangeAspect="1"/>
           </p:cNvPicPr>
@@ -11524,7 +10465,7 @@
       </p:pic>
       <p:sp>
         <p:nvSpPr>
-          <p:cNvPr id="15" name="Text 11"/>
+          <p:cNvPr id="13" name="Text 9"/>
           <p:cNvSpPr txBox="1"/>
           <p:nvPr/>
         </p:nvSpPr>
@@ -11563,7 +10504,7 @@
       </p:sp>
       <p:sp>
         <p:nvSpPr>
-          <p:cNvPr id="16" name="Text 12"/>
+          <p:cNvPr id="14" name="Text 10"/>
           <p:cNvSpPr txBox="1"/>
           <p:nvPr/>
         </p:nvSpPr>
@@ -11690,7 +10631,7 @@
       </p:sp>
       <p:sp>
         <p:nvSpPr>
-          <p:cNvPr id="17" name="Text 13"/>
+          <p:cNvPr id="15" name="Text 11"/>
           <p:cNvSpPr txBox="1"/>
           <p:nvPr/>
         </p:nvSpPr>
@@ -11729,7 +10670,7 @@
       </p:sp>
       <p:sp>
         <p:nvSpPr>
-          <p:cNvPr id="18" name="Text 14"/>
+          <p:cNvPr id="16" name="Text 12"/>
           <p:cNvSpPr txBox="1"/>
           <p:nvPr/>
         </p:nvSpPr>
@@ -11768,7 +10709,7 @@
       </p:sp>
       <p:sp>
         <p:nvSpPr>
-          <p:cNvPr id="19" name="Text 15"/>
+          <p:cNvPr id="17" name="Text 13"/>
           <p:cNvSpPr txBox="1"/>
           <p:nvPr/>
         </p:nvSpPr>
@@ -11917,68 +10858,7 @@
       </p:sp>
       <p:sp>
         <p:nvSpPr>
-          <p:cNvPr id="4" name="Shape 2"/>
-          <p:cNvSpPr/>
-          <p:nvPr/>
-        </p:nvSpPr>
-        <p:spPr>
-          <a:xfrm>
-            <a:off x="9537192" y="384048"/>
-            <a:ext cx="1737360" cy="411480"/>
-          </a:xfrm>
-          <a:prstGeom prst="roundRect">
-            <a:avLst>
-              <a:gd name="adj" fmla="val 17778"/>
-            </a:avLst>
-          </a:prstGeom>
-          <a:solidFill>
-            <a:srgbClr val="C9A227"/>
-          </a:solidFill>
-          <a:ln/>
-        </p:spPr>
-      </p:sp>
-      <p:sp>
-        <p:nvSpPr>
-          <p:cNvPr id="5" name="Text 3"/>
-          <p:cNvSpPr txBox="1"/>
-          <p:nvPr/>
-        </p:nvSpPr>
-        <p:spPr>
-          <a:xfrm>
-            <a:off x="9537192" y="384048"/>
-            <a:ext cx="1737360" cy="411480"/>
-          </a:xfrm>
-          <a:prstGeom prst="rect">
-            <a:avLst/>
-          </a:prstGeom>
-          <a:noFill/>
-          <a:ln/>
-        </p:spPr>
-        <p:txBody>
-          <a:bodyPr wrap="square" lIns="0" tIns="0" rIns="0" bIns="0" rtlCol="0" anchor="ctr"/>
-          <a:lstStyle/>
-          <a:p>
-            <a:pPr algn="ctr" indent="0" marL="0">
-              <a:buNone/>
-            </a:pPr>
-            <a:r>
-              <a:rPr lang="en-US" sz="1300" b="1" spc="50" kern="0" dirty="0">
-                <a:solidFill>
-                  <a:srgbClr val="141B45"/>
-                </a:solidFill>
-                <a:latin typeface="Calibri" pitchFamily="34" charset="0"/>
-                <a:ea typeface="Calibri" pitchFamily="34" charset="-122"/>
-                <a:cs typeface="Calibri" pitchFamily="34" charset="-120"/>
-              </a:rPr>
-              <a:t>2 MARKS</a:t>
-            </a:r>
-            <a:endParaRPr lang="en-US" sz="1300" dirty="0"/>
-          </a:p>
-        </p:txBody>
-      </p:sp>
-      <p:sp>
-        <p:nvSpPr>
-          <p:cNvPr id="6" name="Text 4"/>
+          <p:cNvPr id="4" name="Text 2"/>
           <p:cNvSpPr txBox="1"/>
           <p:nvPr/>
         </p:nvSpPr>
@@ -12017,7 +10897,7 @@
       </p:sp>
       <p:sp>
         <p:nvSpPr>
-          <p:cNvPr id="7" name="Text 5"/>
+          <p:cNvPr id="5" name="Text 3"/>
           <p:cNvSpPr txBox="1"/>
           <p:nvPr/>
         </p:nvSpPr>
@@ -12059,7 +10939,7 @@
       </p:sp>
       <p:sp>
         <p:nvSpPr>
-          <p:cNvPr id="8" name="Shape 6"/>
+          <p:cNvPr id="6" name="Shape 4"/>
           <p:cNvSpPr/>
           <p:nvPr/>
         </p:nvSpPr>
@@ -12081,7 +10961,7 @@
       </p:sp>
       <p:sp>
         <p:nvSpPr>
-          <p:cNvPr id="9" name="Shape 7"/>
+          <p:cNvPr id="7" name="Shape 5"/>
           <p:cNvSpPr/>
           <p:nvPr/>
         </p:nvSpPr>
@@ -12101,7 +10981,7 @@
       </p:sp>
       <p:pic>
         <p:nvPicPr>
-          <p:cNvPr id="10" name="Image 0" descr="preencoded.png">    </p:cNvPr>
+          <p:cNvPr id="8" name="Image 0" descr="preencoded.png">    </p:cNvPr>
           <p:cNvPicPr>
             <a:picLocks noChangeAspect="1"/>
           </p:cNvPicPr>
@@ -12125,7 +11005,7 @@
       </p:pic>
       <p:sp>
         <p:nvSpPr>
-          <p:cNvPr id="11" name="Text 8"/>
+          <p:cNvPr id="9" name="Text 6"/>
           <p:cNvSpPr txBox="1"/>
           <p:nvPr/>
         </p:nvSpPr>
@@ -12164,7 +11044,7 @@
       </p:sp>
       <p:sp>
         <p:nvSpPr>
-          <p:cNvPr id="12" name="Text 9"/>
+          <p:cNvPr id="10" name="Text 7"/>
           <p:cNvSpPr txBox="1"/>
           <p:nvPr/>
         </p:nvSpPr>
@@ -12249,7 +11129,7 @@
       </p:sp>
       <p:sp>
         <p:nvSpPr>
-          <p:cNvPr id="13" name="Shape 10"/>
+          <p:cNvPr id="11" name="Shape 8"/>
           <p:cNvSpPr/>
           <p:nvPr/>
         </p:nvSpPr>
@@ -12272,7 +11152,7 @@
       </p:sp>
       <p:sp>
         <p:nvSpPr>
-          <p:cNvPr id="14" name="Text 11"/>
+          <p:cNvPr id="12" name="Text 9"/>
           <p:cNvSpPr txBox="1"/>
           <p:nvPr/>
         </p:nvSpPr>
@@ -12311,7 +11191,7 @@
       </p:sp>
       <p:sp>
         <p:nvSpPr>
-          <p:cNvPr id="15" name="Shape 12"/>
+          <p:cNvPr id="13" name="Shape 10"/>
           <p:cNvSpPr/>
           <p:nvPr/>
         </p:nvSpPr>
@@ -12333,7 +11213,7 @@
       </p:sp>
       <p:sp>
         <p:nvSpPr>
-          <p:cNvPr id="16" name="Shape 13"/>
+          <p:cNvPr id="14" name="Shape 11"/>
           <p:cNvSpPr/>
           <p:nvPr/>
         </p:nvSpPr>
@@ -12353,7 +11233,7 @@
       </p:sp>
       <p:pic>
         <p:nvPicPr>
-          <p:cNvPr id="17" name="Image 1" descr="preencoded.png">    </p:cNvPr>
+          <p:cNvPr id="15" name="Image 1" descr="preencoded.png">    </p:cNvPr>
           <p:cNvPicPr>
             <a:picLocks noChangeAspect="1"/>
           </p:cNvPicPr>
@@ -12377,7 +11257,7 @@
       </p:pic>
       <p:sp>
         <p:nvSpPr>
-          <p:cNvPr id="18" name="Text 14"/>
+          <p:cNvPr id="16" name="Text 12"/>
           <p:cNvSpPr txBox="1"/>
           <p:nvPr/>
         </p:nvSpPr>
@@ -12416,7 +11296,7 @@
       </p:sp>
       <p:sp>
         <p:nvSpPr>
-          <p:cNvPr id="19" name="Text 15"/>
+          <p:cNvPr id="17" name="Text 13"/>
           <p:cNvSpPr txBox="1"/>
           <p:nvPr/>
         </p:nvSpPr>
@@ -12501,7 +11381,7 @@
       </p:sp>
       <p:sp>
         <p:nvSpPr>
-          <p:cNvPr id="20" name="Shape 16"/>
+          <p:cNvPr id="18" name="Shape 14"/>
           <p:cNvSpPr/>
           <p:nvPr/>
         </p:nvSpPr>
@@ -12524,7 +11404,7 @@
       </p:sp>
       <p:sp>
         <p:nvSpPr>
-          <p:cNvPr id="21" name="Text 17"/>
+          <p:cNvPr id="19" name="Text 15"/>
           <p:cNvSpPr txBox="1"/>
           <p:nvPr/>
         </p:nvSpPr>
@@ -12563,7 +11443,7 @@
       </p:sp>
       <p:sp>
         <p:nvSpPr>
-          <p:cNvPr id="22" name="Text 18"/>
+          <p:cNvPr id="20" name="Text 16"/>
           <p:cNvSpPr txBox="1"/>
           <p:nvPr/>
         </p:nvSpPr>
@@ -12602,7 +11482,7 @@
       </p:sp>
       <p:sp>
         <p:nvSpPr>
-          <p:cNvPr id="23" name="Text 19"/>
+          <p:cNvPr id="21" name="Text 17"/>
           <p:cNvSpPr txBox="1"/>
           <p:nvPr/>
         </p:nvSpPr>
@@ -12796,67 +11676,6 @@
         </p:nvSpPr>
         <p:spPr>
           <a:xfrm>
-            <a:off x="9537192" y="384048"/>
-            <a:ext cx="1737360" cy="411480"/>
-          </a:xfrm>
-          <a:prstGeom prst="roundRect">
-            <a:avLst>
-              <a:gd name="adj" fmla="val 17778"/>
-            </a:avLst>
-          </a:prstGeom>
-          <a:solidFill>
-            <a:srgbClr val="C9A227"/>
-          </a:solidFill>
-          <a:ln/>
-        </p:spPr>
-      </p:sp>
-      <p:sp>
-        <p:nvSpPr>
-          <p:cNvPr id="6" name="Text 4"/>
-          <p:cNvSpPr txBox="1"/>
-          <p:nvPr/>
-        </p:nvSpPr>
-        <p:spPr>
-          <a:xfrm>
-            <a:off x="9537192" y="384048"/>
-            <a:ext cx="1737360" cy="411480"/>
-          </a:xfrm>
-          <a:prstGeom prst="rect">
-            <a:avLst/>
-          </a:prstGeom>
-          <a:noFill/>
-          <a:ln/>
-        </p:spPr>
-        <p:txBody>
-          <a:bodyPr wrap="square" lIns="0" tIns="0" rIns="0" bIns="0" rtlCol="0" anchor="ctr"/>
-          <a:lstStyle/>
-          <a:p>
-            <a:pPr algn="ctr" indent="0" marL="0">
-              <a:buNone/>
-            </a:pPr>
-            <a:r>
-              <a:rPr lang="en-US" sz="1300" b="1" spc="50" kern="0" dirty="0">
-                <a:solidFill>
-                  <a:srgbClr val="141B45"/>
-                </a:solidFill>
-                <a:latin typeface="Calibri" pitchFamily="34" charset="0"/>
-                <a:ea typeface="Calibri" pitchFamily="34" charset="-122"/>
-                <a:cs typeface="Calibri" pitchFamily="34" charset="-120"/>
-              </a:rPr>
-              <a:t>5 MARKS</a:t>
-            </a:r>
-            <a:endParaRPr lang="en-US" sz="1300" dirty="0"/>
-          </a:p>
-        </p:txBody>
-      </p:sp>
-      <p:sp>
-        <p:nvSpPr>
-          <p:cNvPr id="7" name="Shape 5"/>
-          <p:cNvSpPr/>
-          <p:nvPr/>
-        </p:nvSpPr>
-        <p:spPr>
-          <a:xfrm>
             <a:off x="1371600" y="1600200"/>
             <a:ext cx="9418320" cy="960120"/>
           </a:xfrm>
@@ -12873,7 +11692,7 @@
       </p:sp>
       <p:sp>
         <p:nvSpPr>
-          <p:cNvPr id="8" name="Text 6"/>
+          <p:cNvPr id="6" name="Text 4"/>
           <p:cNvSpPr txBox="1"/>
           <p:nvPr/>
         </p:nvSpPr>
@@ -12912,7 +11731,7 @@
       </p:sp>
       <p:sp>
         <p:nvSpPr>
-          <p:cNvPr id="9" name="Text 7"/>
+          <p:cNvPr id="7" name="Text 5"/>
           <p:cNvSpPr txBox="1"/>
           <p:nvPr/>
         </p:nvSpPr>
@@ -12951,7 +11770,7 @@
       </p:sp>
       <p:sp>
         <p:nvSpPr>
-          <p:cNvPr id="10" name="Text 8"/>
+          <p:cNvPr id="8" name="Text 6"/>
           <p:cNvSpPr txBox="1"/>
           <p:nvPr/>
         </p:nvSpPr>
@@ -12990,7 +11809,7 @@
       </p:sp>
       <p:sp>
         <p:nvSpPr>
-          <p:cNvPr id="11" name="Shape 9"/>
+          <p:cNvPr id="9" name="Shape 7"/>
           <p:cNvSpPr/>
           <p:nvPr/>
         </p:nvSpPr>
@@ -13010,7 +11829,7 @@
       </p:sp>
       <p:sp>
         <p:nvSpPr>
-          <p:cNvPr id="12" name="Shape 10"/>
+          <p:cNvPr id="10" name="Shape 8"/>
           <p:cNvSpPr/>
           <p:nvPr/>
         </p:nvSpPr>
@@ -13032,7 +11851,7 @@
       </p:sp>
       <p:sp>
         <p:nvSpPr>
-          <p:cNvPr id="13" name="Text 11"/>
+          <p:cNvPr id="11" name="Text 9"/>
           <p:cNvSpPr txBox="1"/>
           <p:nvPr/>
         </p:nvSpPr>
@@ -13071,7 +11890,7 @@
       </p:sp>
       <p:sp>
         <p:nvSpPr>
-          <p:cNvPr id="14" name="Text 12"/>
+          <p:cNvPr id="12" name="Text 10"/>
           <p:cNvSpPr txBox="1"/>
           <p:nvPr/>
         </p:nvSpPr>
@@ -13110,7 +11929,7 @@
       </p:sp>
       <p:sp>
         <p:nvSpPr>
-          <p:cNvPr id="15" name="Text 13"/>
+          <p:cNvPr id="13" name="Text 11"/>
           <p:cNvSpPr txBox="1"/>
           <p:nvPr/>
         </p:nvSpPr>
@@ -13149,7 +11968,7 @@
       </p:sp>
       <p:sp>
         <p:nvSpPr>
-          <p:cNvPr id="16" name="Shape 14"/>
+          <p:cNvPr id="14" name="Shape 12"/>
           <p:cNvSpPr/>
           <p:nvPr/>
         </p:nvSpPr>
@@ -13169,7 +11988,7 @@
       </p:sp>
       <p:sp>
         <p:nvSpPr>
-          <p:cNvPr id="17" name="Shape 15"/>
+          <p:cNvPr id="15" name="Shape 13"/>
           <p:cNvSpPr/>
           <p:nvPr/>
         </p:nvSpPr>
@@ -13191,7 +12010,7 @@
       </p:sp>
       <p:sp>
         <p:nvSpPr>
-          <p:cNvPr id="18" name="Text 16"/>
+          <p:cNvPr id="16" name="Text 14"/>
           <p:cNvSpPr txBox="1"/>
           <p:nvPr/>
         </p:nvSpPr>
@@ -13230,7 +12049,7 @@
       </p:sp>
       <p:sp>
         <p:nvSpPr>
-          <p:cNvPr id="19" name="Text 17"/>
+          <p:cNvPr id="17" name="Text 15"/>
           <p:cNvSpPr txBox="1"/>
           <p:nvPr/>
         </p:nvSpPr>
@@ -13315,7 +12134,7 @@
       </p:sp>
       <p:sp>
         <p:nvSpPr>
-          <p:cNvPr id="20" name="Shape 18"/>
+          <p:cNvPr id="18" name="Shape 16"/>
           <p:cNvSpPr/>
           <p:nvPr/>
         </p:nvSpPr>
@@ -13337,7 +12156,7 @@
       </p:sp>
       <p:sp>
         <p:nvSpPr>
-          <p:cNvPr id="21" name="Text 19"/>
+          <p:cNvPr id="19" name="Text 17"/>
           <p:cNvSpPr txBox="1"/>
           <p:nvPr/>
         </p:nvSpPr>
@@ -13376,7 +12195,7 @@
       </p:sp>
       <p:sp>
         <p:nvSpPr>
-          <p:cNvPr id="22" name="Text 20"/>
+          <p:cNvPr id="20" name="Text 18"/>
           <p:cNvSpPr txBox="1"/>
           <p:nvPr/>
         </p:nvSpPr>
@@ -13440,7 +12259,7 @@
       </p:sp>
       <p:sp>
         <p:nvSpPr>
-          <p:cNvPr id="23" name="Text 21"/>
+          <p:cNvPr id="21" name="Text 19"/>
           <p:cNvSpPr txBox="1"/>
           <p:nvPr/>
         </p:nvSpPr>
@@ -13479,7 +12298,7 @@
       </p:sp>
       <p:sp>
         <p:nvSpPr>
-          <p:cNvPr id="24" name="Text 22"/>
+          <p:cNvPr id="22" name="Text 20"/>
           <p:cNvSpPr txBox="1"/>
           <p:nvPr/>
         </p:nvSpPr>
@@ -13518,7 +12337,7 @@
       </p:sp>
       <p:sp>
         <p:nvSpPr>
-          <p:cNvPr id="25" name="Text 23"/>
+          <p:cNvPr id="23" name="Text 21"/>
           <p:cNvSpPr txBox="1"/>
           <p:nvPr/>
         </p:nvSpPr>
@@ -14801,68 +13620,7 @@
       </p:pic>
       <p:sp>
         <p:nvSpPr>
-          <p:cNvPr id="7" name="Shape 4"/>
-          <p:cNvSpPr/>
-          <p:nvPr/>
-        </p:nvSpPr>
-        <p:spPr>
-          <a:xfrm>
-            <a:off x="9537192" y="384048"/>
-            <a:ext cx="1737360" cy="411480"/>
-          </a:xfrm>
-          <a:prstGeom prst="roundRect">
-            <a:avLst>
-              <a:gd name="adj" fmla="val 17778"/>
-            </a:avLst>
-          </a:prstGeom>
-          <a:solidFill>
-            <a:srgbClr val="C9A227"/>
-          </a:solidFill>
-          <a:ln/>
-        </p:spPr>
-      </p:sp>
-      <p:sp>
-        <p:nvSpPr>
-          <p:cNvPr id="8" name="Text 5"/>
-          <p:cNvSpPr txBox="1"/>
-          <p:nvPr/>
-        </p:nvSpPr>
-        <p:spPr>
-          <a:xfrm>
-            <a:off x="9537192" y="384048"/>
-            <a:ext cx="1737360" cy="411480"/>
-          </a:xfrm>
-          <a:prstGeom prst="rect">
-            <a:avLst/>
-          </a:prstGeom>
-          <a:noFill/>
-          <a:ln/>
-        </p:spPr>
-        <p:txBody>
-          <a:bodyPr wrap="square" lIns="0" tIns="0" rIns="0" bIns="0" rtlCol="0" anchor="ctr"/>
-          <a:lstStyle/>
-          <a:p>
-            <a:pPr algn="ctr" indent="0" marL="0">
-              <a:buNone/>
-            </a:pPr>
-            <a:r>
-              <a:rPr lang="en-US" sz="1300" b="1" spc="50" kern="0" dirty="0">
-                <a:solidFill>
-                  <a:srgbClr val="141B45"/>
-                </a:solidFill>
-                <a:latin typeface="Calibri" pitchFamily="34" charset="0"/>
-                <a:ea typeface="Calibri" pitchFamily="34" charset="-122"/>
-                <a:cs typeface="Calibri" pitchFamily="34" charset="-120"/>
-              </a:rPr>
-              <a:t>13 MARKS</a:t>
-            </a:r>
-            <a:endParaRPr lang="en-US" sz="1300" dirty="0"/>
-          </a:p>
-        </p:txBody>
-      </p:sp>
-      <p:sp>
-        <p:nvSpPr>
-          <p:cNvPr id="9" name="Text 6"/>
+          <p:cNvPr id="7" name="Text 4"/>
           <p:cNvSpPr txBox="1"/>
           <p:nvPr/>
         </p:nvSpPr>
@@ -14968,7 +13726,7 @@
       </p:sp>
       <p:sp>
         <p:nvSpPr>
-          <p:cNvPr id="10" name="Shape 7"/>
+          <p:cNvPr id="8" name="Shape 5"/>
           <p:cNvSpPr/>
           <p:nvPr/>
         </p:nvSpPr>
@@ -14990,7 +13748,7 @@
       </p:sp>
       <p:sp>
         <p:nvSpPr>
-          <p:cNvPr id="11" name="Text 8"/>
+          <p:cNvPr id="9" name="Text 6"/>
           <p:cNvSpPr txBox="1"/>
           <p:nvPr/>
         </p:nvSpPr>
@@ -15029,7 +13787,7 @@
       </p:sp>
       <p:sp>
         <p:nvSpPr>
-          <p:cNvPr id="12" name="Text 9"/>
+          <p:cNvPr id="10" name="Text 7"/>
           <p:cNvSpPr txBox="1"/>
           <p:nvPr/>
         </p:nvSpPr>
@@ -15068,7 +13826,7 @@
       </p:sp>
       <p:sp>
         <p:nvSpPr>
-          <p:cNvPr id="13" name="Text 10"/>
+          <p:cNvPr id="11" name="Text 8"/>
           <p:cNvSpPr txBox="1"/>
           <p:nvPr/>
         </p:nvSpPr>
@@ -15107,7 +13865,7 @@
       </p:sp>
       <p:sp>
         <p:nvSpPr>
-          <p:cNvPr id="14" name="Text 11"/>
+          <p:cNvPr id="12" name="Text 9"/>
           <p:cNvSpPr txBox="1"/>
           <p:nvPr/>
         </p:nvSpPr>

</xml_diff>